<commit_message>
AI quick start: rewrite for the GitHub Copilot desktop app, with screenshots
Covers the app's real flow: + next to Projects > Open folder, a session
in Current checkout, the model and mode chips under the prompt box,
attaching the excise .md with @, /context to watch credits, and commit
and push. Screenshots from GitHub's MIT-licensed 'GitHub Copilot app
for Beginners' course, credited in the deck and doc.

Co-Authored-By: Claude Opus 5.5 <noreply@anthropic.com>
Claude-Session: https://claude.ai/code/session_01RpqXLYeMJosQsdhqgJkes9
</commit_message>
<xml_diff>
--- a/user_guide/AI_Tools_Quick_Start.pptx
+++ b/user_guide/AI_Tools_Quick_Start.pptx
@@ -8,6 +8,9 @@
     <p:sldId id="256" r:id="rId7"/>
     <p:sldId id="257" r:id="rId8"/>
     <p:sldId id="258" r:id="rId9"/>
+    <p:sldId id="259" r:id="rId10"/>
+    <p:sldId id="260" r:id="rId11"/>
+    <p:sldId id="261" r:id="rId12"/>
   </p:sldIdLst>
   <p:sldSz cx="12191695" cy="6858000" type="screen4x3"/>
   <p:notesSz cx="6858000" cy="9144000"/>
@@ -3142,8 +3145,8 @@
         </p:nvSpPr>
         <p:spPr>
           <a:xfrm>
-            <a:off x="731520" y="822960"/>
-            <a:ext cx="10515600" cy="914400"/>
+            <a:off x="731520" y="731520"/>
+            <a:ext cx="10058400" cy="365760"/>
           </a:xfrm>
           <a:prstGeom prst="rect">
             <a:avLst/>
@@ -3158,37 +3161,154 @@
           <a:p>
             <a:pPr>
               <a:spcAft>
-                <a:spcPts val="600"/>
+                <a:spcPts val="500"/>
               </a:spcAft>
             </a:pPr>
             <a:r>
-              <a:rPr sz="4000" b="1">
-                <a:solidFill>
-                  <a:srgbClr val="FFFFFF"/>
+              <a:rPr sz="1300" b="1" i="0">
+                <a:solidFill>
+                  <a:srgbClr val="C9A227"/>
                 </a:solidFill>
                 <a:latin typeface="Arial"/>
               </a:rPr>
-              <a:t>AI Tools Quick Start (GitHub Copilot)</a:t>
-            </a:r>
-          </a:p>
-        </p:txBody>
-      </p:sp>
-      <p:sp>
-        <p:nvSpPr>
-          <p:cNvPr id="4" name="Rectangle 3"/>
+              <a:t>USER GUIDE · GITHUB COPILOT APP</a:t>
+            </a:r>
+          </a:p>
+        </p:txBody>
+      </p:sp>
+      <p:sp>
+        <p:nvSpPr>
+          <p:cNvPr id="4" name="TextBox 3"/>
+          <p:cNvSpPr txBox="1"/>
+          <p:nvPr/>
+        </p:nvSpPr>
+        <p:spPr>
+          <a:xfrm>
+            <a:off x="731520" y="1143000"/>
+            <a:ext cx="10515600" cy="822960"/>
+          </a:xfrm>
+          <a:prstGeom prst="rect">
+            <a:avLst/>
+          </a:prstGeom>
+          <a:noFill/>
+        </p:spPr>
+        <p:txBody>
+          <a:bodyPr wrap="square">
+            <a:spAutoFit/>
+          </a:bodyPr>
+          <a:lstStyle/>
+          <a:p>
+            <a:pPr>
+              <a:spcAft>
+                <a:spcPts val="500"/>
+              </a:spcAft>
+            </a:pPr>
+            <a:r>
+              <a:rPr sz="4400" b="1" i="0">
+                <a:solidFill>
+                  <a:srgbClr val="FFFFFF"/>
+                </a:solidFill>
+                <a:latin typeface="Arial"/>
+              </a:rPr>
+              <a:t>AI Tools Quick Start</a:t>
+            </a:r>
+          </a:p>
+        </p:txBody>
+      </p:sp>
+      <p:sp>
+        <p:nvSpPr>
+          <p:cNvPr id="5" name="TextBox 4"/>
+          <p:cNvSpPr txBox="1"/>
+          <p:nvPr/>
+        </p:nvSpPr>
+        <p:spPr>
+          <a:xfrm>
+            <a:off x="731520" y="1965960"/>
+            <a:ext cx="10515600" cy="457200"/>
+          </a:xfrm>
+          <a:prstGeom prst="rect">
+            <a:avLst/>
+          </a:prstGeom>
+          <a:noFill/>
+        </p:spPr>
+        <p:txBody>
+          <a:bodyPr wrap="square">
+            <a:spAutoFit/>
+          </a:bodyPr>
+          <a:lstStyle/>
+          <a:p>
+            <a:pPr>
+              <a:spcAft>
+                <a:spcPts val="500"/>
+              </a:spcAft>
+            </a:pPr>
+            <a:r>
+              <a:rPr sz="1800" b="0" i="0">
+                <a:solidFill>
+                  <a:srgbClr val="D9E2F3"/>
+                </a:solidFill>
+                <a:latin typeface="Arial"/>
+              </a:rPr>
+              <a:t>Two examples with the GitHub Copilot app: an excise diagnostic for Indonesia, and new tax indicators in the dashboard.</a:t>
+            </a:r>
+          </a:p>
+        </p:txBody>
+      </p:sp>
+      <p:sp>
+        <p:nvSpPr>
+          <p:cNvPr id="6" name="TextBox 5"/>
+          <p:cNvSpPr txBox="1"/>
+          <p:nvPr/>
+        </p:nvSpPr>
+        <p:spPr>
+          <a:xfrm>
+            <a:off x="731520" y="2926080"/>
+            <a:ext cx="10515600" cy="365760"/>
+          </a:xfrm>
+          <a:prstGeom prst="rect">
+            <a:avLst/>
+          </a:prstGeom>
+          <a:noFill/>
+        </p:spPr>
+        <p:txBody>
+          <a:bodyPr wrap="square">
+            <a:spAutoFit/>
+          </a:bodyPr>
+          <a:lstStyle/>
+          <a:p>
+            <a:pPr>
+              <a:spcAft>
+                <a:spcPts val="500"/>
+              </a:spcAft>
+            </a:pPr>
+            <a:r>
+              <a:rPr sz="1800" b="1" i="0">
+                <a:solidFill>
+                  <a:srgbClr val="C9A227"/>
+                </a:solidFill>
+                <a:latin typeface="Arial"/>
+              </a:rPr>
+              <a:t>We assume you already have</a:t>
+            </a:r>
+          </a:p>
+        </p:txBody>
+      </p:sp>
+      <p:sp>
+        <p:nvSpPr>
+          <p:cNvPr id="7" name="Oval 6"/>
           <p:cNvSpPr/>
           <p:nvPr/>
         </p:nvSpPr>
         <p:spPr>
           <a:xfrm>
-            <a:off x="731520" y="1828800"/>
-            <a:ext cx="1097280" cy="73152"/>
-          </a:xfrm>
-          <a:prstGeom prst="rect">
+            <a:off x="731520" y="3429000"/>
+            <a:ext cx="365760" cy="365760"/>
+          </a:xfrm>
+          <a:prstGeom prst="ellipse">
             <a:avLst/>
           </a:prstGeom>
           <a:solidFill>
-            <a:srgbClr val="C9A227"/>
+            <a:srgbClr val="3A7D44"/>
           </a:solidFill>
           <a:ln>
             <a:noFill/>
@@ -3214,19 +3334,27 @@
           <a:lstStyle/>
           <a:p>
             <a:pPr algn="ctr"/>
-          </a:p>
-        </p:txBody>
-      </p:sp>
-      <p:sp>
-        <p:nvSpPr>
-          <p:cNvPr id="5" name="TextBox 4"/>
+            <a:r>
+              <a:rPr sz="1400" b="1">
+                <a:solidFill>
+                  <a:srgbClr val="FFFFFF"/>
+                </a:solidFill>
+              </a:rPr>
+              <a:t>✓</a:t>
+            </a:r>
+          </a:p>
+        </p:txBody>
+      </p:sp>
+      <p:sp>
+        <p:nvSpPr>
+          <p:cNvPr id="8" name="TextBox 7"/>
           <p:cNvSpPr txBox="1"/>
           <p:nvPr/>
         </p:nvSpPr>
         <p:spPr>
           <a:xfrm>
-            <a:off x="731520" y="2286000"/>
-            <a:ext cx="10515600" cy="457200"/>
+            <a:off x="1280160" y="3410712"/>
+            <a:ext cx="10058400" cy="548640"/>
           </a:xfrm>
           <a:prstGeom prst="rect">
             <a:avLst/>
@@ -3241,31 +3369,83 @@
           <a:p>
             <a:pPr>
               <a:spcAft>
-                <a:spcPts val="600"/>
+                <a:spcPts val="500"/>
               </a:spcAft>
             </a:pPr>
             <a:r>
-              <a:rPr sz="1800" b="1">
-                <a:solidFill>
-                  <a:srgbClr val="C9A227"/>
+              <a:rPr sz="1700" b="0" i="0">
+                <a:solidFill>
+                  <a:srgbClr val="FFFFFF"/>
                 </a:solidFill>
                 <a:latin typeface="Arial"/>
               </a:rPr>
-              <a:t>You need</a:t>
-            </a:r>
-          </a:p>
-        </p:txBody>
-      </p:sp>
-      <p:sp>
-        <p:nvSpPr>
-          <p:cNvPr id="6" name="TextBox 5"/>
+              <a:t>The new-ai-tools repo downloaded on your laptop (C:\Users\&lt;you&gt;\Repos\new-ai-tools) and up to date.</a:t>
+            </a:r>
+          </a:p>
+        </p:txBody>
+      </p:sp>
+      <p:sp>
+        <p:nvSpPr>
+          <p:cNvPr id="9" name="Oval 8"/>
+          <p:cNvSpPr/>
+          <p:nvPr/>
+        </p:nvSpPr>
+        <p:spPr>
+          <a:xfrm>
+            <a:off x="731520" y="4069080"/>
+            <a:ext cx="365760" cy="365760"/>
+          </a:xfrm>
+          <a:prstGeom prst="ellipse">
+            <a:avLst/>
+          </a:prstGeom>
+          <a:solidFill>
+            <a:srgbClr val="3A7D44"/>
+          </a:solidFill>
+          <a:ln>
+            <a:noFill/>
+          </a:ln>
+          <a:effectLst/>
+        </p:spPr>
+        <p:style>
+          <a:lnRef idx="1">
+            <a:schemeClr val="accent1"/>
+          </a:lnRef>
+          <a:fillRef idx="3">
+            <a:schemeClr val="accent1"/>
+          </a:fillRef>
+          <a:effectRef idx="2">
+            <a:schemeClr val="accent1"/>
+          </a:effectRef>
+          <a:fontRef idx="minor">
+            <a:schemeClr val="lt1"/>
+          </a:fontRef>
+        </p:style>
+        <p:txBody>
+          <a:bodyPr rtlCol="0" anchor="ctr"/>
+          <a:lstStyle/>
+          <a:p>
+            <a:pPr algn="ctr"/>
+            <a:r>
+              <a:rPr sz="1400" b="1">
+                <a:solidFill>
+                  <a:srgbClr val="FFFFFF"/>
+                </a:solidFill>
+              </a:rPr>
+              <a:t>✓</a:t>
+            </a:r>
+          </a:p>
+        </p:txBody>
+      </p:sp>
+      <p:sp>
+        <p:nvSpPr>
+          <p:cNvPr id="10" name="TextBox 9"/>
           <p:cNvSpPr txBox="1"/>
           <p:nvPr/>
         </p:nvSpPr>
         <p:spPr>
           <a:xfrm>
-            <a:off x="731520" y="2743200"/>
-            <a:ext cx="10515600" cy="548640"/>
+            <a:off x="1280160" y="4050792"/>
+            <a:ext cx="10058400" cy="548640"/>
           </a:xfrm>
           <a:prstGeom prst="rect">
             <a:avLst/>
@@ -3280,31 +3460,31 @@
           <a:p>
             <a:pPr>
               <a:spcAft>
-                <a:spcPts val="600"/>
+                <a:spcPts val="500"/>
               </a:spcAft>
             </a:pPr>
             <a:r>
-              <a:rPr sz="2000" b="0">
+              <a:rPr sz="1700" b="0" i="0">
                 <a:solidFill>
                   <a:srgbClr val="FFFFFF"/>
                 </a:solidFill>
                 <a:latin typeface="Arial"/>
               </a:rPr>
-              <a:t>The new-ai-tools repo on your laptop, and GitHub Copilot in VS Code.</a:t>
-            </a:r>
-          </a:p>
-        </p:txBody>
-      </p:sp>
-      <p:sp>
-        <p:nvSpPr>
-          <p:cNvPr id="7" name="TextBox 6"/>
+              <a:t>The GitHub Copilot app installed (Microsoft Store) and signed in with your GitHub account.</a:t>
+            </a:r>
+          </a:p>
+        </p:txBody>
+      </p:sp>
+      <p:sp>
+        <p:nvSpPr>
+          <p:cNvPr id="11" name="TextBox 10"/>
           <p:cNvSpPr txBox="1"/>
           <p:nvPr/>
         </p:nvSpPr>
         <p:spPr>
           <a:xfrm>
-            <a:off x="731520" y="3566160"/>
-            <a:ext cx="10515600" cy="457200"/>
+            <a:off x="1280160" y="4709160"/>
+            <a:ext cx="10058400" cy="365760"/>
           </a:xfrm>
           <a:prstGeom prst="rect">
             <a:avLst/>
@@ -3319,31 +3499,31 @@
           <a:p>
             <a:pPr>
               <a:spcAft>
-                <a:spcPts val="600"/>
+                <a:spcPts val="500"/>
               </a:spcAft>
             </a:pPr>
             <a:r>
-              <a:rPr sz="1800" b="1">
-                <a:solidFill>
-                  <a:srgbClr val="C9A227"/>
+              <a:rPr sz="1300" b="0" i="1">
+                <a:solidFill>
+                  <a:srgbClr val="D9E2F3"/>
                 </a:solidFill>
                 <a:latin typeface="Arial"/>
               </a:rPr>
-              <a:t>To start</a:t>
-            </a:r>
-          </a:p>
-        </p:txBody>
-      </p:sp>
-      <p:sp>
-        <p:nvSpPr>
-          <p:cNvPr id="8" name="TextBox 7"/>
+              <a:t>Not there yet? See Presentations/GitHub_Copilot_AI_User_Guide.pptx.</a:t>
+            </a:r>
+          </a:p>
+        </p:txBody>
+      </p:sp>
+      <p:sp>
+        <p:nvSpPr>
+          <p:cNvPr id="12" name="TextBox 11"/>
           <p:cNvSpPr txBox="1"/>
           <p:nvPr/>
         </p:nvSpPr>
         <p:spPr>
           <a:xfrm>
-            <a:off x="731520" y="4023360"/>
-            <a:ext cx="10515600" cy="914400"/>
+            <a:off x="731520" y="5303520"/>
+            <a:ext cx="10515600" cy="457200"/>
           </a:xfrm>
           <a:prstGeom prst="rect">
             <a:avLst/>
@@ -3358,56 +3538,17 @@
           <a:p>
             <a:pPr>
               <a:spcAft>
-                <a:spcPts val="600"/>
+                <a:spcPts val="500"/>
               </a:spcAft>
             </a:pPr>
             <a:r>
-              <a:rPr sz="2000" b="0">
+              <a:rPr sz="1500" b="1" i="0">
                 <a:solidFill>
                   <a:srgbClr val="FFFFFF"/>
                 </a:solidFill>
                 <a:latin typeface="Arial"/>
               </a:rPr>
-              <a:t>Open the repo in VS Code, click Sync, open Copilot Chat in Agent mode. Paste one prompt. Read the answer. Then paste the next.</a:t>
-            </a:r>
-          </a:p>
-        </p:txBody>
-      </p:sp>
-      <p:sp>
-        <p:nvSpPr>
-          <p:cNvPr id="9" name="TextBox 8"/>
-          <p:cNvSpPr txBox="1"/>
-          <p:nvPr/>
-        </p:nvSpPr>
-        <p:spPr>
-          <a:xfrm>
-            <a:off x="731520" y="5760720"/>
-            <a:ext cx="10515600" cy="731520"/>
-          </a:xfrm>
-          <a:prstGeom prst="rect">
-            <a:avLst/>
-          </a:prstGeom>
-          <a:noFill/>
-        </p:spPr>
-        <p:txBody>
-          <a:bodyPr wrap="square">
-            <a:spAutoFit/>
-          </a:bodyPr>
-          <a:lstStyle/>
-          <a:p>
-            <a:pPr>
-              <a:spcAft>
-                <a:spcPts val="600"/>
-              </a:spcAft>
-            </a:pPr>
-            <a:r>
-              <a:rPr sz="1300" b="0">
-                <a:solidFill>
-                  <a:srgbClr val="D9E2F3"/>
-                </a:solidFill>
-                <a:latin typeface="Arial"/>
-              </a:rPr>
-              <a:t>Appendix – With Claude instead: make a Claude Project, add excise_diagnostic_process.md to it, switch on Research, and paste the same prompts.</a:t>
+              <a:t>Steps 1-2 set up a session. Then do Example 1 or Example 2. Step 3 saves your work.</a:t>
             </a:r>
           </a:p>
         </p:txBody>
@@ -3482,8 +3623,8 @@
         </p:nvSpPr>
         <p:spPr>
           <a:xfrm>
-            <a:off x="640080" y="365760"/>
-            <a:ext cx="10972800" cy="731520"/>
+            <a:off x="548640" y="274320"/>
+            <a:ext cx="10972800" cy="320040"/>
           </a:xfrm>
           <a:prstGeom prst="rect">
             <a:avLst/>
@@ -3498,17 +3639,17 @@
           <a:p>
             <a:pPr>
               <a:spcAft>
-                <a:spcPts val="600"/>
+                <a:spcPts val="500"/>
               </a:spcAft>
             </a:pPr>
             <a:r>
-              <a:rPr sz="3000" b="1">
-                <a:solidFill>
-                  <a:srgbClr val="1F3864"/>
+              <a:rPr sz="1200" b="1" i="0">
+                <a:solidFill>
+                  <a:srgbClr val="C9A227"/>
                 </a:solidFill>
                 <a:latin typeface="Arial"/>
               </a:rPr>
-              <a:t>1. Excise diagnostic for Indonesia</a:t>
+              <a:t>STEP 1 · ONCE PER TASK</a:t>
             </a:r>
           </a:p>
         </p:txBody>
@@ -3521,8 +3662,8 @@
         </p:nvSpPr>
         <p:spPr>
           <a:xfrm>
-            <a:off x="640080" y="1097280"/>
-            <a:ext cx="4572000" cy="457200"/>
+            <a:off x="548640" y="548640"/>
+            <a:ext cx="10972800" cy="640080"/>
           </a:xfrm>
           <a:prstGeom prst="rect">
             <a:avLst/>
@@ -3537,37 +3678,76 @@
           <a:p>
             <a:pPr>
               <a:spcAft>
-                <a:spcPts val="600"/>
+                <a:spcPts val="500"/>
               </a:spcAft>
             </a:pPr>
             <a:r>
-              <a:rPr sz="1600" b="1">
-                <a:solidFill>
-                  <a:srgbClr val="2E75B6"/>
+              <a:rPr sz="2800" b="1" i="0">
+                <a:solidFill>
+                  <a:srgbClr val="1F3864"/>
                 </a:solidFill>
                 <a:latin typeface="Arial"/>
               </a:rPr>
-              <a:t>Model: Claude Opus</a:t>
-            </a:r>
-          </a:p>
-        </p:txBody>
-      </p:sp>
-      <p:sp>
-        <p:nvSpPr>
-          <p:cNvPr id="5" name="Rectangle 4"/>
+              <a:t>Open the repo and start a session</a:t>
+            </a:r>
+          </a:p>
+        </p:txBody>
+      </p:sp>
+      <p:sp>
+        <p:nvSpPr>
+          <p:cNvPr id="5" name="TextBox 4"/>
+          <p:cNvSpPr txBox="1"/>
+          <p:nvPr/>
+        </p:nvSpPr>
+        <p:spPr>
+          <a:xfrm>
+            <a:off x="548640" y="6446520"/>
+            <a:ext cx="11155680" cy="274320"/>
+          </a:xfrm>
+          <a:prstGeom prst="rect">
+            <a:avLst/>
+          </a:prstGeom>
+          <a:noFill/>
+        </p:spPr>
+        <p:txBody>
+          <a:bodyPr wrap="square">
+            <a:spAutoFit/>
+          </a:bodyPr>
+          <a:lstStyle/>
+          <a:p>
+            <a:pPr>
+              <a:spcAft>
+                <a:spcPts val="500"/>
+              </a:spcAft>
+            </a:pPr>
+            <a:r>
+              <a:rPr sz="900" b="0" i="0">
+                <a:solidFill>
+                  <a:srgbClr val="808080"/>
+                </a:solidFill>
+                <a:latin typeface="Arial"/>
+              </a:rPr>
+              <a:t>AI Tools Quick Start  ·  GitHub Copilot app  ·  October 2026  ·  Screens change over time</a:t>
+            </a:r>
+          </a:p>
+        </p:txBody>
+      </p:sp>
+      <p:sp>
+        <p:nvSpPr>
+          <p:cNvPr id="6" name="Oval 5"/>
           <p:cNvSpPr/>
           <p:nvPr/>
         </p:nvSpPr>
         <p:spPr>
           <a:xfrm>
-            <a:off x="5486400" y="1051560"/>
-            <a:ext cx="6126480" cy="502920"/>
-          </a:xfrm>
-          <a:prstGeom prst="rect">
+            <a:off x="548640" y="1463040"/>
+            <a:ext cx="384048" cy="384048"/>
+          </a:xfrm>
+          <a:prstGeom prst="ellipse">
             <a:avLst/>
           </a:prstGeom>
           <a:solidFill>
-            <a:srgbClr val="FDECEA"/>
+            <a:srgbClr val="2E75B6"/>
           </a:solidFill>
           <a:ln>
             <a:noFill/>
@@ -3589,23 +3769,32 @@
           </a:fontRef>
         </p:style>
         <p:txBody>
-          <a:bodyPr rtlCol="0" anchor="ctr"/>
+          <a:bodyPr rtlCol="0" anchor="ctr" lIns="0" rIns="0"/>
           <a:lstStyle/>
           <a:p>
             <a:pPr algn="ctr"/>
-          </a:p>
-        </p:txBody>
-      </p:sp>
-      <p:sp>
-        <p:nvSpPr>
-          <p:cNvPr id="6" name="TextBox 5"/>
+            <a:r>
+              <a:rPr sz="1400" b="1">
+                <a:solidFill>
+                  <a:srgbClr val="FFFFFF"/>
+                </a:solidFill>
+                <a:latin typeface="Arial"/>
+              </a:rPr>
+              <a:t>1</a:t>
+            </a:r>
+          </a:p>
+        </p:txBody>
+      </p:sp>
+      <p:sp>
+        <p:nvSpPr>
+          <p:cNvPr id="7" name="TextBox 6"/>
           <p:cNvSpPr txBox="1"/>
           <p:nvPr/>
         </p:nvSpPr>
         <p:spPr>
           <a:xfrm>
-            <a:off x="5623560" y="1078992"/>
-            <a:ext cx="5943600" cy="457200"/>
+            <a:off x="1051560" y="1426464"/>
+            <a:ext cx="3703320" cy="320040"/>
           </a:xfrm>
           <a:prstGeom prst="rect">
             <a:avLst/>
@@ -3620,31 +3809,31 @@
           <a:p>
             <a:pPr>
               <a:spcAft>
-                <a:spcPts val="600"/>
+                <a:spcPts val="500"/>
               </a:spcAft>
             </a:pPr>
             <a:r>
-              <a:rPr sz="1600" b="1">
-                <a:solidFill>
-                  <a:srgbClr val="C0392B"/>
+              <a:rPr sz="1500" b="1" i="0">
+                <a:solidFill>
+                  <a:srgbClr val="1F3864"/>
                 </a:solidFill>
                 <a:latin typeface="Arial"/>
               </a:rPr>
-              <a:t>⚠  Uses a lot of credits: one prompt at a time.</a:t>
-            </a:r>
-          </a:p>
-        </p:txBody>
-      </p:sp>
-      <p:sp>
-        <p:nvSpPr>
-          <p:cNvPr id="7" name="TextBox 6"/>
+              <a:t>Add the repo (first time only)</a:t>
+            </a:r>
+          </a:p>
+        </p:txBody>
+      </p:sp>
+      <p:sp>
+        <p:nvSpPr>
+          <p:cNvPr id="8" name="TextBox 7"/>
           <p:cNvSpPr txBox="1"/>
           <p:nvPr/>
         </p:nvSpPr>
         <p:spPr>
           <a:xfrm>
-            <a:off x="640080" y="1783080"/>
-            <a:ext cx="10972800" cy="365760"/>
+            <a:off x="1051560" y="1737360"/>
+            <a:ext cx="3703320" cy="1097280"/>
           </a:xfrm>
           <a:prstGeom prst="rect">
             <a:avLst/>
@@ -3659,76 +3848,37 @@
           <a:p>
             <a:pPr>
               <a:spcAft>
-                <a:spcPts val="600"/>
+                <a:spcPts val="500"/>
               </a:spcAft>
             </a:pPr>
             <a:r>
-              <a:rPr sz="1300" b="0">
+              <a:rPr sz="1200" b="0" i="0">
                 <a:solidFill>
                   <a:srgbClr val="404040"/>
                 </a:solidFill>
                 <a:latin typeface="Arial"/>
               </a:rPr>
-              <a:t>First, attach excise_diagnostic_process.md to the chat (drag it in, or click Add Context). It is the instruction file Copilot follows.</a:t>
-            </a:r>
-          </a:p>
-        </p:txBody>
-      </p:sp>
-      <p:sp>
-        <p:nvSpPr>
-          <p:cNvPr id="8" name="TextBox 7"/>
-          <p:cNvSpPr txBox="1"/>
-          <p:nvPr/>
-        </p:nvSpPr>
-        <p:spPr>
-          <a:xfrm>
-            <a:off x="640080" y="2240280"/>
-            <a:ext cx="10972800" cy="365760"/>
-          </a:xfrm>
-          <a:prstGeom prst="rect">
-            <a:avLst/>
-          </a:prstGeom>
-          <a:noFill/>
-        </p:spPr>
-        <p:txBody>
-          <a:bodyPr wrap="square">
-            <a:spAutoFit/>
-          </a:bodyPr>
-          <a:lstStyle/>
-          <a:p>
-            <a:pPr>
-              <a:spcAft>
-                <a:spcPts val="600"/>
-              </a:spcAft>
-            </a:pPr>
-            <a:r>
-              <a:rPr sz="1400" b="1">
-                <a:solidFill>
-                  <a:srgbClr val="1F3864"/>
-                </a:solidFill>
-                <a:latin typeface="Arial"/>
-              </a:rPr>
-              <a:t>Paste:</a:t>
-            </a:r>
-          </a:p>
-        </p:txBody>
-      </p:sp>
-      <p:sp>
-        <p:nvSpPr>
-          <p:cNvPr id="9" name="Rectangle 8"/>
+              <a:t>In the sidebar, click + next to Projects, then Open folder. Pick Repos\new-ai-tools. It stays in the sidebar.</a:t>
+            </a:r>
+          </a:p>
+        </p:txBody>
+      </p:sp>
+      <p:sp>
+        <p:nvSpPr>
+          <p:cNvPr id="9" name="Oval 8"/>
           <p:cNvSpPr/>
           <p:nvPr/>
         </p:nvSpPr>
         <p:spPr>
           <a:xfrm>
-            <a:off x="640080" y="2651760"/>
-            <a:ext cx="10972800" cy="548640"/>
-          </a:xfrm>
-          <a:prstGeom prst="rect">
+            <a:off x="548640" y="2834640"/>
+            <a:ext cx="384048" cy="384048"/>
+          </a:xfrm>
+          <a:prstGeom prst="ellipse">
             <a:avLst/>
           </a:prstGeom>
           <a:solidFill>
-            <a:srgbClr val="F2F2F2"/>
+            <a:srgbClr val="2E75B6"/>
           </a:solidFill>
           <a:ln>
             <a:noFill/>
@@ -3750,10 +3900,19 @@
           </a:fontRef>
         </p:style>
         <p:txBody>
-          <a:bodyPr rtlCol="0" anchor="ctr"/>
+          <a:bodyPr rtlCol="0" anchor="ctr" lIns="0" rIns="0"/>
           <a:lstStyle/>
           <a:p>
             <a:pPr algn="ctr"/>
+            <a:r>
+              <a:rPr sz="1400" b="1">
+                <a:solidFill>
+                  <a:srgbClr val="FFFFFF"/>
+                </a:solidFill>
+                <a:latin typeface="Arial"/>
+              </a:rPr>
+              <a:t>2</a:t>
+            </a:r>
           </a:p>
         </p:txBody>
       </p:sp>
@@ -3765,8 +3924,8 @@
         </p:nvSpPr>
         <p:spPr>
           <a:xfrm>
-            <a:off x="777240" y="2697480"/>
-            <a:ext cx="10698480" cy="548640"/>
+            <a:off x="1051560" y="2798064"/>
+            <a:ext cx="3703320" cy="320040"/>
           </a:xfrm>
           <a:prstGeom prst="rect">
             <a:avLst/>
@@ -3781,17 +3940,17 @@
           <a:p>
             <a:pPr>
               <a:spcAft>
-                <a:spcPts val="600"/>
+                <a:spcPts val="500"/>
               </a:spcAft>
             </a:pPr>
             <a:r>
-              <a:rPr sz="1500" b="0">
-                <a:solidFill>
-                  <a:srgbClr val="262626"/>
-                </a:solidFill>
-                <a:latin typeface="Consolas"/>
+              <a:rPr sz="1500" b="1" i="0">
+                <a:solidFill>
+                  <a:srgbClr val="1F3864"/>
+                </a:solidFill>
+                <a:latin typeface="Arial"/>
               </a:rPr>
-              <a:t>Using the attached file, run stage A1 for Indonesia, 2020 to 2026-09-30. Stop after A1.</a:t>
+              <a:t>Start a session</a:t>
             </a:r>
           </a:p>
         </p:txBody>
@@ -3804,8 +3963,8 @@
         </p:nvSpPr>
         <p:spPr>
           <a:xfrm>
-            <a:off x="640080" y="3474720"/>
-            <a:ext cx="10972800" cy="365760"/>
+            <a:off x="1051560" y="3108960"/>
+            <a:ext cx="3703320" cy="1097280"/>
           </a:xfrm>
           <a:prstGeom prst="rect">
             <a:avLst/>
@@ -3820,37 +3979,37 @@
           <a:p>
             <a:pPr>
               <a:spcAft>
-                <a:spcPts val="600"/>
+                <a:spcPts val="500"/>
               </a:spcAft>
             </a:pPr>
             <a:r>
-              <a:rPr sz="1400" b="1">
-                <a:solidFill>
-                  <a:srgbClr val="1F3864"/>
+              <a:rPr sz="1200" b="0" i="0">
+                <a:solidFill>
+                  <a:srgbClr val="404040"/>
                 </a:solidFill>
                 <a:latin typeface="Arial"/>
               </a:rPr>
-              <a:t>Then, one at a time:</a:t>
-            </a:r>
-          </a:p>
-        </p:txBody>
-      </p:sp>
-      <p:sp>
-        <p:nvSpPr>
-          <p:cNvPr id="12" name="Rectangle 11"/>
+              <a:t>Point at new-ai-tools in the sidebar and click the + next to it.</a:t>
+            </a:r>
+          </a:p>
+        </p:txBody>
+      </p:sp>
+      <p:sp>
+        <p:nvSpPr>
+          <p:cNvPr id="12" name="Oval 11"/>
           <p:cNvSpPr/>
           <p:nvPr/>
         </p:nvSpPr>
         <p:spPr>
           <a:xfrm>
-            <a:off x="640080" y="3886200"/>
-            <a:ext cx="10972800" cy="384048"/>
-          </a:xfrm>
-          <a:prstGeom prst="rect">
+            <a:off x="548640" y="4206240"/>
+            <a:ext cx="384048" cy="384048"/>
+          </a:xfrm>
+          <a:prstGeom prst="ellipse">
             <a:avLst/>
           </a:prstGeom>
           <a:solidFill>
-            <a:srgbClr val="F2F2F2"/>
+            <a:srgbClr val="2E75B6"/>
           </a:solidFill>
           <a:ln>
             <a:noFill/>
@@ -3872,10 +4031,19 @@
           </a:fontRef>
         </p:style>
         <p:txBody>
-          <a:bodyPr rtlCol="0" anchor="ctr"/>
+          <a:bodyPr rtlCol="0" anchor="ctr" lIns="0" rIns="0"/>
           <a:lstStyle/>
           <a:p>
             <a:pPr algn="ctr"/>
+            <a:r>
+              <a:rPr sz="1400" b="1">
+                <a:solidFill>
+                  <a:srgbClr val="FFFFFF"/>
+                </a:solidFill>
+                <a:latin typeface="Arial"/>
+              </a:rPr>
+              <a:t>3</a:t>
+            </a:r>
           </a:p>
         </p:txBody>
       </p:sp>
@@ -3887,8 +4055,8 @@
         </p:nvSpPr>
         <p:spPr>
           <a:xfrm>
-            <a:off x="777240" y="3895344"/>
-            <a:ext cx="10698480" cy="384048"/>
+            <a:off x="1051560" y="4169663"/>
+            <a:ext cx="3703320" cy="320040"/>
           </a:xfrm>
           <a:prstGeom prst="rect">
             <a:avLst/>
@@ -3903,37 +4071,76 @@
           <a:p>
             <a:pPr>
               <a:spcAft>
-                <a:spcPts val="600"/>
+                <a:spcPts val="500"/>
               </a:spcAft>
             </a:pPr>
             <a:r>
-              <a:rPr sz="1300" b="0">
-                <a:solidFill>
-                  <a:srgbClr val="262626"/>
-                </a:solidFill>
-                <a:latin typeface="Consolas"/>
+              <a:rPr sz="1500" b="1" i="0">
+                <a:solidFill>
+                  <a:srgbClr val="1F3864"/>
+                </a:solidFill>
+                <a:latin typeface="Arial"/>
               </a:rPr>
-              <a:t>Run stage A2.</a:t>
-            </a:r>
-          </a:p>
-        </p:txBody>
-      </p:sp>
-      <p:sp>
-        <p:nvSpPr>
-          <p:cNvPr id="14" name="Rectangle 13"/>
+              <a:t>Work in your folder</a:t>
+            </a:r>
+          </a:p>
+        </p:txBody>
+      </p:sp>
+      <p:sp>
+        <p:nvSpPr>
+          <p:cNvPr id="14" name="TextBox 13"/>
+          <p:cNvSpPr txBox="1"/>
+          <p:nvPr/>
+        </p:nvSpPr>
+        <p:spPr>
+          <a:xfrm>
+            <a:off x="1051560" y="4480559"/>
+            <a:ext cx="3703320" cy="1097280"/>
+          </a:xfrm>
+          <a:prstGeom prst="rect">
+            <a:avLst/>
+          </a:prstGeom>
+          <a:noFill/>
+        </p:spPr>
+        <p:txBody>
+          <a:bodyPr wrap="square">
+            <a:spAutoFit/>
+          </a:bodyPr>
+          <a:lstStyle/>
+          <a:p>
+            <a:pPr>
+              <a:spcAft>
+                <a:spcPts val="500"/>
+              </a:spcAft>
+            </a:pPr>
+            <a:r>
+              <a:rPr sz="1200" b="0" i="0">
+                <a:solidFill>
+                  <a:srgbClr val="404040"/>
+                </a:solidFill>
+                <a:latin typeface="Arial"/>
+              </a:rPr>
+              <a:t>Under the prompt box, open the workspace selector and choose Current checkout. Copilot then edits the repo folder on your laptop.</a:t>
+            </a:r>
+          </a:p>
+        </p:txBody>
+      </p:sp>
+      <p:sp>
+        <p:nvSpPr>
+          <p:cNvPr id="15" name="Rectangle 14"/>
           <p:cNvSpPr/>
           <p:nvPr/>
         </p:nvSpPr>
         <p:spPr>
           <a:xfrm>
-            <a:off x="640080" y="4343400"/>
-            <a:ext cx="10972800" cy="384048"/>
+            <a:off x="5001768" y="1344168"/>
+            <a:ext cx="6729983" cy="2108747"/>
           </a:xfrm>
           <a:prstGeom prst="rect">
             <a:avLst/>
           </a:prstGeom>
           <a:solidFill>
-            <a:srgbClr val="F2F2F2"/>
+            <a:srgbClr val="BFBFBF"/>
           </a:solidFill>
           <a:ln>
             <a:noFill/>
@@ -3962,16 +4169,40 @@
           </a:p>
         </p:txBody>
       </p:sp>
-      <p:sp>
-        <p:nvSpPr>
-          <p:cNvPr id="15" name="TextBox 14"/>
+      <p:pic>
+        <p:nvPicPr>
+          <p:cNvPr id="16" name="Picture 15" descr="s_addproj.png"/>
+          <p:cNvPicPr>
+            <a:picLocks noChangeAspect="1"/>
+          </p:cNvPicPr>
+          <p:nvPr/>
+        </p:nvPicPr>
+        <p:blipFill>
+          <a:blip r:embed="rId2"/>
+          <a:stretch>
+            <a:fillRect/>
+          </a:stretch>
+        </p:blipFill>
+        <p:spPr>
+          <a:xfrm>
+            <a:off x="5029200" y="1371600"/>
+            <a:ext cx="6675120" cy="2053883"/>
+          </a:xfrm>
+          <a:prstGeom prst="rect">
+            <a:avLst/>
+          </a:prstGeom>
+        </p:spPr>
+      </p:pic>
+      <p:sp>
+        <p:nvSpPr>
+          <p:cNvPr id="17" name="TextBox 16"/>
           <p:cNvSpPr txBox="1"/>
           <p:nvPr/>
         </p:nvSpPr>
         <p:spPr>
           <a:xfrm>
-            <a:off x="777240" y="4352544"/>
-            <a:ext cx="10698480" cy="384048"/>
+            <a:off x="5029200" y="3471203"/>
+            <a:ext cx="6675120" cy="274320"/>
           </a:xfrm>
           <a:prstGeom prst="rect">
             <a:avLst/>
@@ -3986,37 +4217,37 @@
           <a:p>
             <a:pPr>
               <a:spcAft>
-                <a:spcPts val="600"/>
+                <a:spcPts val="500"/>
               </a:spcAft>
             </a:pPr>
             <a:r>
-              <a:rPr sz="1300" b="0">
-                <a:solidFill>
-                  <a:srgbClr val="262626"/>
-                </a:solidFill>
-                <a:latin typeface="Consolas"/>
+              <a:rPr sz="1100" b="0" i="1">
+                <a:solidFill>
+                  <a:srgbClr val="404040"/>
+                </a:solidFill>
+                <a:latin typeface="Arial"/>
               </a:rPr>
-              <a:t>Run stage A3.</a:t>
-            </a:r>
-          </a:p>
-        </p:txBody>
-      </p:sp>
-      <p:sp>
-        <p:nvSpPr>
-          <p:cNvPr id="16" name="Rectangle 15"/>
+              <a:t>+ next to Projects, then Open folder</a:t>
+            </a:r>
+          </a:p>
+        </p:txBody>
+      </p:sp>
+      <p:sp>
+        <p:nvSpPr>
+          <p:cNvPr id="18" name="Rectangle 17"/>
           <p:cNvSpPr/>
           <p:nvPr/>
         </p:nvSpPr>
         <p:spPr>
           <a:xfrm>
-            <a:off x="640080" y="4800600"/>
-            <a:ext cx="10972800" cy="384048"/>
+            <a:off x="6196203" y="3950207"/>
+            <a:ext cx="4341114" cy="2112264"/>
           </a:xfrm>
           <a:prstGeom prst="rect">
             <a:avLst/>
           </a:prstGeom>
           <a:solidFill>
-            <a:srgbClr val="F2F2F2"/>
+            <a:srgbClr val="BFBFBF"/>
           </a:solidFill>
           <a:ln>
             <a:noFill/>
@@ -4045,16 +4276,40 @@
           </a:p>
         </p:txBody>
       </p:sp>
-      <p:sp>
-        <p:nvSpPr>
-          <p:cNvPr id="17" name="TextBox 16"/>
+      <p:pic>
+        <p:nvPicPr>
+          <p:cNvPr id="19" name="Picture 18" descr="s_checkout.png"/>
+          <p:cNvPicPr>
+            <a:picLocks noChangeAspect="1"/>
+          </p:cNvPicPr>
+          <p:nvPr/>
+        </p:nvPicPr>
+        <p:blipFill>
+          <a:blip r:embed="rId3"/>
+          <a:stretch>
+            <a:fillRect/>
+          </a:stretch>
+        </p:blipFill>
+        <p:spPr>
+          <a:xfrm>
+            <a:off x="6223635" y="3977639"/>
+            <a:ext cx="4286250" cy="2057400"/>
+          </a:xfrm>
+          <a:prstGeom prst="rect">
+            <a:avLst/>
+          </a:prstGeom>
+        </p:spPr>
+      </p:pic>
+      <p:sp>
+        <p:nvSpPr>
+          <p:cNvPr id="20" name="TextBox 19"/>
           <p:cNvSpPr txBox="1"/>
           <p:nvPr/>
         </p:nvSpPr>
         <p:spPr>
           <a:xfrm>
-            <a:off x="777240" y="4809744"/>
-            <a:ext cx="10698480" cy="384048"/>
+            <a:off x="5029200" y="6080759"/>
+            <a:ext cx="6675120" cy="274320"/>
           </a:xfrm>
           <a:prstGeom prst="rect">
             <a:avLst/>
@@ -4069,266 +4324,17 @@
           <a:p>
             <a:pPr>
               <a:spcAft>
-                <a:spcPts val="600"/>
+                <a:spcPts val="500"/>
               </a:spcAft>
             </a:pPr>
             <a:r>
-              <a:rPr sz="1300" b="0">
-                <a:solidFill>
-                  <a:srgbClr val="262626"/>
-                </a:solidFill>
-                <a:latin typeface="Consolas"/>
-              </a:rPr>
-              <a:t>Run stage A4.</a:t>
-            </a:r>
-          </a:p>
-        </p:txBody>
-      </p:sp>
-      <p:sp>
-        <p:nvSpPr>
-          <p:cNvPr id="18" name="Rectangle 17"/>
-          <p:cNvSpPr/>
-          <p:nvPr/>
-        </p:nvSpPr>
-        <p:spPr>
-          <a:xfrm>
-            <a:off x="640080" y="5257800"/>
-            <a:ext cx="10972800" cy="384048"/>
-          </a:xfrm>
-          <a:prstGeom prst="rect">
-            <a:avLst/>
-          </a:prstGeom>
-          <a:solidFill>
-            <a:srgbClr val="F2F2F2"/>
-          </a:solidFill>
-          <a:ln>
-            <a:noFill/>
-          </a:ln>
-          <a:effectLst/>
-        </p:spPr>
-        <p:style>
-          <a:lnRef idx="1">
-            <a:schemeClr val="accent1"/>
-          </a:lnRef>
-          <a:fillRef idx="3">
-            <a:schemeClr val="accent1"/>
-          </a:fillRef>
-          <a:effectRef idx="2">
-            <a:schemeClr val="accent1"/>
-          </a:effectRef>
-          <a:fontRef idx="minor">
-            <a:schemeClr val="lt1"/>
-          </a:fontRef>
-        </p:style>
-        <p:txBody>
-          <a:bodyPr rtlCol="0" anchor="ctr"/>
-          <a:lstStyle/>
-          <a:p>
-            <a:pPr algn="ctr"/>
-          </a:p>
-        </p:txBody>
-      </p:sp>
-      <p:sp>
-        <p:nvSpPr>
-          <p:cNvPr id="19" name="TextBox 18"/>
-          <p:cNvSpPr txBox="1"/>
-          <p:nvPr/>
-        </p:nvSpPr>
-        <p:spPr>
-          <a:xfrm>
-            <a:off x="777240" y="5266944"/>
-            <a:ext cx="10698480" cy="384048"/>
-          </a:xfrm>
-          <a:prstGeom prst="rect">
-            <a:avLst/>
-          </a:prstGeom>
-          <a:noFill/>
-        </p:spPr>
-        <p:txBody>
-          <a:bodyPr wrap="square">
-            <a:spAutoFit/>
-          </a:bodyPr>
-          <a:lstStyle/>
-          <a:p>
-            <a:pPr>
-              <a:spcAft>
-                <a:spcPts val="600"/>
-              </a:spcAft>
-            </a:pPr>
-            <a:r>
-              <a:rPr sz="1300" b="0">
-                <a:solidFill>
-                  <a:srgbClr val="262626"/>
-                </a:solidFill>
-                <a:latin typeface="Consolas"/>
-              </a:rPr>
-              <a:t>Run stage A5.</a:t>
-            </a:r>
-          </a:p>
-        </p:txBody>
-      </p:sp>
-      <p:sp>
-        <p:nvSpPr>
-          <p:cNvPr id="20" name="Rectangle 19"/>
-          <p:cNvSpPr/>
-          <p:nvPr/>
-        </p:nvSpPr>
-        <p:spPr>
-          <a:xfrm>
-            <a:off x="640080" y="5715000"/>
-            <a:ext cx="10972800" cy="384048"/>
-          </a:xfrm>
-          <a:prstGeom prst="rect">
-            <a:avLst/>
-          </a:prstGeom>
-          <a:solidFill>
-            <a:srgbClr val="F2F2F2"/>
-          </a:solidFill>
-          <a:ln>
-            <a:noFill/>
-          </a:ln>
-          <a:effectLst/>
-        </p:spPr>
-        <p:style>
-          <a:lnRef idx="1">
-            <a:schemeClr val="accent1"/>
-          </a:lnRef>
-          <a:fillRef idx="3">
-            <a:schemeClr val="accent1"/>
-          </a:fillRef>
-          <a:effectRef idx="2">
-            <a:schemeClr val="accent1"/>
-          </a:effectRef>
-          <a:fontRef idx="minor">
-            <a:schemeClr val="lt1"/>
-          </a:fontRef>
-        </p:style>
-        <p:txBody>
-          <a:bodyPr rtlCol="0" anchor="ctr"/>
-          <a:lstStyle/>
-          <a:p>
-            <a:pPr algn="ctr"/>
-          </a:p>
-        </p:txBody>
-      </p:sp>
-      <p:sp>
-        <p:nvSpPr>
-          <p:cNvPr id="21" name="TextBox 20"/>
-          <p:cNvSpPr txBox="1"/>
-          <p:nvPr/>
-        </p:nvSpPr>
-        <p:spPr>
-          <a:xfrm>
-            <a:off x="777240" y="5724144"/>
-            <a:ext cx="10698480" cy="384048"/>
-          </a:xfrm>
-          <a:prstGeom prst="rect">
-            <a:avLst/>
-          </a:prstGeom>
-          <a:noFill/>
-        </p:spPr>
-        <p:txBody>
-          <a:bodyPr wrap="square">
-            <a:spAutoFit/>
-          </a:bodyPr>
-          <a:lstStyle/>
-          <a:p>
-            <a:pPr>
-              <a:spcAft>
-                <a:spcPts val="600"/>
-              </a:spcAft>
-            </a:pPr>
-            <a:r>
-              <a:rPr sz="1300" b="0">
-                <a:solidFill>
-                  <a:srgbClr val="262626"/>
-                </a:solidFill>
-                <a:latin typeface="Consolas"/>
-              </a:rPr>
-              <a:t>Run stage A6 and save the Word report and Excel workbook in ExciseDiagnostic/country_results/Indonesia/.</a:t>
-            </a:r>
-          </a:p>
-        </p:txBody>
-      </p:sp>
-      <p:sp>
-        <p:nvSpPr>
-          <p:cNvPr id="22" name="Rectangle 21"/>
-          <p:cNvSpPr/>
-          <p:nvPr/>
-        </p:nvSpPr>
-        <p:spPr>
-          <a:xfrm>
-            <a:off x="640080" y="6309360"/>
-            <a:ext cx="10972800" cy="548640"/>
-          </a:xfrm>
-          <a:prstGeom prst="rect">
-            <a:avLst/>
-          </a:prstGeom>
-          <a:solidFill>
-            <a:srgbClr val="EEF3F9"/>
-          </a:solidFill>
-          <a:ln>
-            <a:noFill/>
-          </a:ln>
-          <a:effectLst/>
-        </p:spPr>
-        <p:style>
-          <a:lnRef idx="1">
-            <a:schemeClr val="accent1"/>
-          </a:lnRef>
-          <a:fillRef idx="3">
-            <a:schemeClr val="accent1"/>
-          </a:fillRef>
-          <a:effectRef idx="2">
-            <a:schemeClr val="accent1"/>
-          </a:effectRef>
-          <a:fontRef idx="minor">
-            <a:schemeClr val="lt1"/>
-          </a:fontRef>
-        </p:style>
-        <p:txBody>
-          <a:bodyPr rtlCol="0" anchor="ctr"/>
-          <a:lstStyle/>
-          <a:p>
-            <a:pPr algn="ctr"/>
-          </a:p>
-        </p:txBody>
-      </p:sp>
-      <p:sp>
-        <p:nvSpPr>
-          <p:cNvPr id="23" name="TextBox 22"/>
-          <p:cNvSpPr txBox="1"/>
-          <p:nvPr/>
-        </p:nvSpPr>
-        <p:spPr>
-          <a:xfrm>
-            <a:off x="777240" y="6373368"/>
-            <a:ext cx="10698480" cy="457200"/>
-          </a:xfrm>
-          <a:prstGeom prst="rect">
-            <a:avLst/>
-          </a:prstGeom>
-          <a:noFill/>
-        </p:spPr>
-        <p:txBody>
-          <a:bodyPr wrap="square">
-            <a:spAutoFit/>
-          </a:bodyPr>
-          <a:lstStyle/>
-          <a:p>
-            <a:pPr>
-              <a:spcAft>
-                <a:spcPts val="600"/>
-              </a:spcAft>
-            </a:pPr>
-            <a:r>
-              <a:rPr sz="1500" b="1">
-                <a:solidFill>
-                  <a:srgbClr val="1F3864"/>
+              <a:rPr sz="1100" b="0" i="1">
+                <a:solidFill>
+                  <a:srgbClr val="404040"/>
                 </a:solidFill>
                 <a:latin typeface="Arial"/>
               </a:rPr>
-              <a:t>Check: Every rate has a date and a source link.</a:t>
+              <a:t>Workspace selector, then Current checkout</a:t>
             </a:r>
           </a:p>
         </p:txBody>
@@ -4403,8 +4409,8 @@
         </p:nvSpPr>
         <p:spPr>
           <a:xfrm>
-            <a:off x="640080" y="365760"/>
-            <a:ext cx="10972800" cy="731520"/>
+            <a:off x="548640" y="274320"/>
+            <a:ext cx="10972800" cy="320040"/>
           </a:xfrm>
           <a:prstGeom prst="rect">
             <a:avLst/>
@@ -4419,17 +4425,17 @@
           <a:p>
             <a:pPr>
               <a:spcAft>
-                <a:spcPts val="600"/>
+                <a:spcPts val="500"/>
               </a:spcAft>
             </a:pPr>
             <a:r>
-              <a:rPr sz="3000" b="1">
-                <a:solidFill>
-                  <a:srgbClr val="1F3864"/>
+              <a:rPr sz="1200" b="1" i="0">
+                <a:solidFill>
+                  <a:srgbClr val="C9A227"/>
                 </a:solidFill>
                 <a:latin typeface="Arial"/>
               </a:rPr>
-              <a:t>2. Add tax indicators to the dashboard</a:t>
+              <a:t>STEP 2 · EVERY SESSION</a:t>
             </a:r>
           </a:p>
         </p:txBody>
@@ -4442,8 +4448,8 @@
         </p:nvSpPr>
         <p:spPr>
           <a:xfrm>
-            <a:off x="640080" y="1097280"/>
-            <a:ext cx="4572000" cy="457200"/>
+            <a:off x="548640" y="548640"/>
+            <a:ext cx="10972800" cy="640080"/>
           </a:xfrm>
           <a:prstGeom prst="rect">
             <a:avLst/>
@@ -4458,17 +4464,17 @@
           <a:p>
             <a:pPr>
               <a:spcAft>
-                <a:spcPts val="600"/>
+                <a:spcPts val="500"/>
               </a:spcAft>
             </a:pPr>
             <a:r>
-              <a:rPr sz="1600" b="1">
-                <a:solidFill>
-                  <a:srgbClr val="2E75B6"/>
+              <a:rPr sz="2800" b="1" i="0">
+                <a:solidFill>
+                  <a:srgbClr val="1F3864"/>
                 </a:solidFill>
                 <a:latin typeface="Arial"/>
               </a:rPr>
-              <a:t>Model: Claude Sonnet</a:t>
+              <a:t>Pick the model and the mode</a:t>
             </a:r>
           </a:p>
         </p:txBody>
@@ -4481,8 +4487,8 @@
         </p:nvSpPr>
         <p:spPr>
           <a:xfrm>
-            <a:off x="640080" y="1783080"/>
-            <a:ext cx="10972800" cy="365760"/>
+            <a:off x="548640" y="6446520"/>
+            <a:ext cx="11155680" cy="274320"/>
           </a:xfrm>
           <a:prstGeom prst="rect">
             <a:avLst/>
@@ -4497,11 +4503,1002 @@
           <a:p>
             <a:pPr>
               <a:spcAft>
-                <a:spcPts val="600"/>
+                <a:spcPts val="500"/>
               </a:spcAft>
             </a:pPr>
             <a:r>
+              <a:rPr sz="900" b="0" i="0">
+                <a:solidFill>
+                  <a:srgbClr val="808080"/>
+                </a:solidFill>
+                <a:latin typeface="Arial"/>
+              </a:rPr>
+              <a:t>AI Tools Quick Start  ·  GitHub Copilot app  ·  October 2026  ·  Screens change over time</a:t>
+            </a:r>
+          </a:p>
+        </p:txBody>
+      </p:sp>
+      <p:sp>
+        <p:nvSpPr>
+          <p:cNvPr id="6" name="Oval 5"/>
+          <p:cNvSpPr/>
+          <p:nvPr/>
+        </p:nvSpPr>
+        <p:spPr>
+          <a:xfrm>
+            <a:off x="548640" y="1463040"/>
+            <a:ext cx="384048" cy="384048"/>
+          </a:xfrm>
+          <a:prstGeom prst="ellipse">
+            <a:avLst/>
+          </a:prstGeom>
+          <a:solidFill>
+            <a:srgbClr val="2E75B6"/>
+          </a:solidFill>
+          <a:ln>
+            <a:noFill/>
+          </a:ln>
+          <a:effectLst/>
+        </p:spPr>
+        <p:style>
+          <a:lnRef idx="1">
+            <a:schemeClr val="accent1"/>
+          </a:lnRef>
+          <a:fillRef idx="3">
+            <a:schemeClr val="accent1"/>
+          </a:fillRef>
+          <a:effectRef idx="2">
+            <a:schemeClr val="accent1"/>
+          </a:effectRef>
+          <a:fontRef idx="minor">
+            <a:schemeClr val="lt1"/>
+          </a:fontRef>
+        </p:style>
+        <p:txBody>
+          <a:bodyPr rtlCol="0" anchor="ctr" lIns="0" rIns="0"/>
+          <a:lstStyle/>
+          <a:p>
+            <a:pPr algn="ctr"/>
+            <a:r>
               <a:rPr sz="1400" b="1">
+                <a:solidFill>
+                  <a:srgbClr val="FFFFFF"/>
+                </a:solidFill>
+                <a:latin typeface="Arial"/>
+              </a:rPr>
+              <a:t>1</a:t>
+            </a:r>
+          </a:p>
+        </p:txBody>
+      </p:sp>
+      <p:sp>
+        <p:nvSpPr>
+          <p:cNvPr id="7" name="TextBox 6"/>
+          <p:cNvSpPr txBox="1"/>
+          <p:nvPr/>
+        </p:nvSpPr>
+        <p:spPr>
+          <a:xfrm>
+            <a:off x="1051560" y="1426464"/>
+            <a:ext cx="3703320" cy="320040"/>
+          </a:xfrm>
+          <a:prstGeom prst="rect">
+            <a:avLst/>
+          </a:prstGeom>
+          <a:noFill/>
+        </p:spPr>
+        <p:txBody>
+          <a:bodyPr wrap="square">
+            <a:spAutoFit/>
+          </a:bodyPr>
+          <a:lstStyle/>
+          <a:p>
+            <a:pPr>
+              <a:spcAft>
+                <a:spcPts val="500"/>
+              </a:spcAft>
+            </a:pPr>
+            <a:r>
+              <a:rPr sz="1500" b="1" i="0">
+                <a:solidFill>
+                  <a:srgbClr val="1F3864"/>
+                </a:solidFill>
+                <a:latin typeface="Arial"/>
+              </a:rPr>
+              <a:t>Model</a:t>
+            </a:r>
+          </a:p>
+        </p:txBody>
+      </p:sp>
+      <p:sp>
+        <p:nvSpPr>
+          <p:cNvPr id="8" name="TextBox 7"/>
+          <p:cNvSpPr txBox="1"/>
+          <p:nvPr/>
+        </p:nvSpPr>
+        <p:spPr>
+          <a:xfrm>
+            <a:off x="1051560" y="1737360"/>
+            <a:ext cx="3703320" cy="1097280"/>
+          </a:xfrm>
+          <a:prstGeom prst="rect">
+            <a:avLst/>
+          </a:prstGeom>
+          <a:noFill/>
+        </p:spPr>
+        <p:txBody>
+          <a:bodyPr wrap="square">
+            <a:spAutoFit/>
+          </a:bodyPr>
+          <a:lstStyle/>
+          <a:p>
+            <a:pPr>
+              <a:spcAft>
+                <a:spcPts val="500"/>
+              </a:spcAft>
+            </a:pPr>
+            <a:r>
+              <a:rPr sz="1200" b="0" i="0">
+                <a:solidFill>
+                  <a:srgbClr val="404040"/>
+                </a:solidFill>
+                <a:latin typeface="Arial"/>
+              </a:rPr>
+              <a:t>Click the model chip under the prompt box. Switch Auto off, then pick Model: Claude Sonnet for everyday work, Claude Opus for the excise research.</a:t>
+            </a:r>
+          </a:p>
+        </p:txBody>
+      </p:sp>
+      <p:sp>
+        <p:nvSpPr>
+          <p:cNvPr id="9" name="Oval 8"/>
+          <p:cNvSpPr/>
+          <p:nvPr/>
+        </p:nvSpPr>
+        <p:spPr>
+          <a:xfrm>
+            <a:off x="548640" y="2834640"/>
+            <a:ext cx="384048" cy="384048"/>
+          </a:xfrm>
+          <a:prstGeom prst="ellipse">
+            <a:avLst/>
+          </a:prstGeom>
+          <a:solidFill>
+            <a:srgbClr val="2E75B6"/>
+          </a:solidFill>
+          <a:ln>
+            <a:noFill/>
+          </a:ln>
+          <a:effectLst/>
+        </p:spPr>
+        <p:style>
+          <a:lnRef idx="1">
+            <a:schemeClr val="accent1"/>
+          </a:lnRef>
+          <a:fillRef idx="3">
+            <a:schemeClr val="accent1"/>
+          </a:fillRef>
+          <a:effectRef idx="2">
+            <a:schemeClr val="accent1"/>
+          </a:effectRef>
+          <a:fontRef idx="minor">
+            <a:schemeClr val="lt1"/>
+          </a:fontRef>
+        </p:style>
+        <p:txBody>
+          <a:bodyPr rtlCol="0" anchor="ctr" lIns="0" rIns="0"/>
+          <a:lstStyle/>
+          <a:p>
+            <a:pPr algn="ctr"/>
+            <a:r>
+              <a:rPr sz="1400" b="1">
+                <a:solidFill>
+                  <a:srgbClr val="FFFFFF"/>
+                </a:solidFill>
+                <a:latin typeface="Arial"/>
+              </a:rPr>
+              <a:t>2</a:t>
+            </a:r>
+          </a:p>
+        </p:txBody>
+      </p:sp>
+      <p:sp>
+        <p:nvSpPr>
+          <p:cNvPr id="10" name="TextBox 9"/>
+          <p:cNvSpPr txBox="1"/>
+          <p:nvPr/>
+        </p:nvSpPr>
+        <p:spPr>
+          <a:xfrm>
+            <a:off x="1051560" y="2798064"/>
+            <a:ext cx="3703320" cy="320040"/>
+          </a:xfrm>
+          <a:prstGeom prst="rect">
+            <a:avLst/>
+          </a:prstGeom>
+          <a:noFill/>
+        </p:spPr>
+        <p:txBody>
+          <a:bodyPr wrap="square">
+            <a:spAutoFit/>
+          </a:bodyPr>
+          <a:lstStyle/>
+          <a:p>
+            <a:pPr>
+              <a:spcAft>
+                <a:spcPts val="500"/>
+              </a:spcAft>
+            </a:pPr>
+            <a:r>
+              <a:rPr sz="1500" b="1" i="0">
+                <a:solidFill>
+                  <a:srgbClr val="1F3864"/>
+                </a:solidFill>
+                <a:latin typeface="Arial"/>
+              </a:rPr>
+              <a:t>Mode</a:t>
+            </a:r>
+          </a:p>
+        </p:txBody>
+      </p:sp>
+      <p:sp>
+        <p:nvSpPr>
+          <p:cNvPr id="11" name="TextBox 10"/>
+          <p:cNvSpPr txBox="1"/>
+          <p:nvPr/>
+        </p:nvSpPr>
+        <p:spPr>
+          <a:xfrm>
+            <a:off x="1051560" y="3108960"/>
+            <a:ext cx="3703320" cy="1097280"/>
+          </a:xfrm>
+          <a:prstGeom prst="rect">
+            <a:avLst/>
+          </a:prstGeom>
+          <a:noFill/>
+        </p:spPr>
+        <p:txBody>
+          <a:bodyPr wrap="square">
+            <a:spAutoFit/>
+          </a:bodyPr>
+          <a:lstStyle/>
+          <a:p>
+            <a:pPr>
+              <a:spcAft>
+                <a:spcPts val="500"/>
+              </a:spcAft>
+            </a:pPr>
+            <a:r>
+              <a:rPr sz="1200" b="0" i="0">
+                <a:solidFill>
+                  <a:srgbClr val="404040"/>
+                </a:solidFill>
+                <a:latin typeface="Arial"/>
+              </a:rPr>
+              <a:t>Click the mode chip and pick Interactive: Copilot asks before it acts.</a:t>
+            </a:r>
+          </a:p>
+        </p:txBody>
+      </p:sp>
+      <p:sp>
+        <p:nvSpPr>
+          <p:cNvPr id="12" name="Oval 11"/>
+          <p:cNvSpPr/>
+          <p:nvPr/>
+        </p:nvSpPr>
+        <p:spPr>
+          <a:xfrm>
+            <a:off x="548640" y="4206240"/>
+            <a:ext cx="384048" cy="384048"/>
+          </a:xfrm>
+          <a:prstGeom prst="ellipse">
+            <a:avLst/>
+          </a:prstGeom>
+          <a:solidFill>
+            <a:srgbClr val="2E75B6"/>
+          </a:solidFill>
+          <a:ln>
+            <a:noFill/>
+          </a:ln>
+          <a:effectLst/>
+        </p:spPr>
+        <p:style>
+          <a:lnRef idx="1">
+            <a:schemeClr val="accent1"/>
+          </a:lnRef>
+          <a:fillRef idx="3">
+            <a:schemeClr val="accent1"/>
+          </a:fillRef>
+          <a:effectRef idx="2">
+            <a:schemeClr val="accent1"/>
+          </a:effectRef>
+          <a:fontRef idx="minor">
+            <a:schemeClr val="lt1"/>
+          </a:fontRef>
+        </p:style>
+        <p:txBody>
+          <a:bodyPr rtlCol="0" anchor="ctr" lIns="0" rIns="0"/>
+          <a:lstStyle/>
+          <a:p>
+            <a:pPr algn="ctr"/>
+            <a:r>
+              <a:rPr sz="1400" b="1">
+                <a:solidFill>
+                  <a:srgbClr val="FFFFFF"/>
+                </a:solidFill>
+                <a:latin typeface="Arial"/>
+              </a:rPr>
+              <a:t>3</a:t>
+            </a:r>
+          </a:p>
+        </p:txBody>
+      </p:sp>
+      <p:sp>
+        <p:nvSpPr>
+          <p:cNvPr id="13" name="TextBox 12"/>
+          <p:cNvSpPr txBox="1"/>
+          <p:nvPr/>
+        </p:nvSpPr>
+        <p:spPr>
+          <a:xfrm>
+            <a:off x="1051560" y="4169663"/>
+            <a:ext cx="3703320" cy="320040"/>
+          </a:xfrm>
+          <a:prstGeom prst="rect">
+            <a:avLst/>
+          </a:prstGeom>
+          <a:noFill/>
+        </p:spPr>
+        <p:txBody>
+          <a:bodyPr wrap="square">
+            <a:spAutoFit/>
+          </a:bodyPr>
+          <a:lstStyle/>
+          <a:p>
+            <a:pPr>
+              <a:spcAft>
+                <a:spcPts val="500"/>
+              </a:spcAft>
+            </a:pPr>
+            <a:r>
+              <a:rPr sz="1500" b="1" i="0">
+                <a:solidFill>
+                  <a:srgbClr val="1F3864"/>
+                </a:solidFill>
+                <a:latin typeface="Arial"/>
+              </a:rPr>
+              <a:t>Credits</a:t>
+            </a:r>
+          </a:p>
+        </p:txBody>
+      </p:sp>
+      <p:sp>
+        <p:nvSpPr>
+          <p:cNvPr id="14" name="TextBox 13"/>
+          <p:cNvSpPr txBox="1"/>
+          <p:nvPr/>
+        </p:nvSpPr>
+        <p:spPr>
+          <a:xfrm>
+            <a:off x="1051560" y="4480559"/>
+            <a:ext cx="3703320" cy="1097280"/>
+          </a:xfrm>
+          <a:prstGeom prst="rect">
+            <a:avLst/>
+          </a:prstGeom>
+          <a:noFill/>
+        </p:spPr>
+        <p:txBody>
+          <a:bodyPr wrap="square">
+            <a:spAutoFit/>
+          </a:bodyPr>
+          <a:lstStyle/>
+          <a:p>
+            <a:pPr>
+              <a:spcAft>
+                <a:spcPts val="500"/>
+              </a:spcAft>
+            </a:pPr>
+            <a:r>
+              <a:rPr sz="1200" b="0" i="0">
+                <a:solidFill>
+                  <a:srgbClr val="404040"/>
+                </a:solidFill>
+                <a:latin typeface="Arial"/>
+              </a:rPr>
+              <a:t>Type /context at any time to see the AI credits the session has used.</a:t>
+            </a:r>
+          </a:p>
+        </p:txBody>
+      </p:sp>
+      <p:sp>
+        <p:nvSpPr>
+          <p:cNvPr id="15" name="Rectangle 14"/>
+          <p:cNvSpPr/>
+          <p:nvPr/>
+        </p:nvSpPr>
+        <p:spPr>
+          <a:xfrm>
+            <a:off x="5001768" y="1344168"/>
+            <a:ext cx="6729983" cy="2021640"/>
+          </a:xfrm>
+          <a:prstGeom prst="rect">
+            <a:avLst/>
+          </a:prstGeom>
+          <a:solidFill>
+            <a:srgbClr val="BFBFBF"/>
+          </a:solidFill>
+          <a:ln>
+            <a:noFill/>
+          </a:ln>
+          <a:effectLst/>
+        </p:spPr>
+        <p:style>
+          <a:lnRef idx="1">
+            <a:schemeClr val="accent1"/>
+          </a:lnRef>
+          <a:fillRef idx="3">
+            <a:schemeClr val="accent1"/>
+          </a:fillRef>
+          <a:effectRef idx="2">
+            <a:schemeClr val="accent1"/>
+          </a:effectRef>
+          <a:fontRef idx="minor">
+            <a:schemeClr val="lt1"/>
+          </a:fontRef>
+        </p:style>
+        <p:txBody>
+          <a:bodyPr rtlCol="0" anchor="ctr"/>
+          <a:lstStyle/>
+          <a:p>
+            <a:pPr algn="ctr"/>
+          </a:p>
+        </p:txBody>
+      </p:sp>
+      <p:pic>
+        <p:nvPicPr>
+          <p:cNvPr id="16" name="Picture 15" descr="s_model.png"/>
+          <p:cNvPicPr>
+            <a:picLocks noChangeAspect="1"/>
+          </p:cNvPicPr>
+          <p:nvPr/>
+        </p:nvPicPr>
+        <p:blipFill>
+          <a:blip r:embed="rId2"/>
+          <a:stretch>
+            <a:fillRect/>
+          </a:stretch>
+        </p:blipFill>
+        <p:spPr>
+          <a:xfrm>
+            <a:off x="5029200" y="1371600"/>
+            <a:ext cx="6675120" cy="1966776"/>
+          </a:xfrm>
+          <a:prstGeom prst="rect">
+            <a:avLst/>
+          </a:prstGeom>
+        </p:spPr>
+      </p:pic>
+      <p:sp>
+        <p:nvSpPr>
+          <p:cNvPr id="17" name="TextBox 16"/>
+          <p:cNvSpPr txBox="1"/>
+          <p:nvPr/>
+        </p:nvSpPr>
+        <p:spPr>
+          <a:xfrm>
+            <a:off x="5029200" y="3384096"/>
+            <a:ext cx="6675120" cy="274320"/>
+          </a:xfrm>
+          <a:prstGeom prst="rect">
+            <a:avLst/>
+          </a:prstGeom>
+          <a:noFill/>
+        </p:spPr>
+        <p:txBody>
+          <a:bodyPr wrap="square">
+            <a:spAutoFit/>
+          </a:bodyPr>
+          <a:lstStyle/>
+          <a:p>
+            <a:pPr>
+              <a:spcAft>
+                <a:spcPts val="500"/>
+              </a:spcAft>
+            </a:pPr>
+            <a:r>
+              <a:rPr sz="1100" b="0" i="1">
+                <a:solidFill>
+                  <a:srgbClr val="404040"/>
+                </a:solidFill>
+                <a:latin typeface="Arial"/>
+              </a:rPr>
+              <a:t>Model chip: Auto off, then Model</a:t>
+            </a:r>
+          </a:p>
+        </p:txBody>
+      </p:sp>
+      <p:sp>
+        <p:nvSpPr>
+          <p:cNvPr id="18" name="Rectangle 17"/>
+          <p:cNvSpPr/>
+          <p:nvPr/>
+        </p:nvSpPr>
+        <p:spPr>
+          <a:xfrm>
+            <a:off x="6205728" y="3950207"/>
+            <a:ext cx="4322064" cy="2112264"/>
+          </a:xfrm>
+          <a:prstGeom prst="rect">
+            <a:avLst/>
+          </a:prstGeom>
+          <a:solidFill>
+            <a:srgbClr val="BFBFBF"/>
+          </a:solidFill>
+          <a:ln>
+            <a:noFill/>
+          </a:ln>
+          <a:effectLst/>
+        </p:spPr>
+        <p:style>
+          <a:lnRef idx="1">
+            <a:schemeClr val="accent1"/>
+          </a:lnRef>
+          <a:fillRef idx="3">
+            <a:schemeClr val="accent1"/>
+          </a:fillRef>
+          <a:effectRef idx="2">
+            <a:schemeClr val="accent1"/>
+          </a:effectRef>
+          <a:fontRef idx="minor">
+            <a:schemeClr val="lt1"/>
+          </a:fontRef>
+        </p:style>
+        <p:txBody>
+          <a:bodyPr rtlCol="0" anchor="ctr"/>
+          <a:lstStyle/>
+          <a:p>
+            <a:pPr algn="ctr"/>
+          </a:p>
+        </p:txBody>
+      </p:sp>
+      <p:pic>
+        <p:nvPicPr>
+          <p:cNvPr id="19" name="Picture 18" descr="s_modes.png"/>
+          <p:cNvPicPr>
+            <a:picLocks noChangeAspect="1"/>
+          </p:cNvPicPr>
+          <p:nvPr/>
+        </p:nvPicPr>
+        <p:blipFill>
+          <a:blip r:embed="rId3"/>
+          <a:stretch>
+            <a:fillRect/>
+          </a:stretch>
+        </p:blipFill>
+        <p:spPr>
+          <a:xfrm>
+            <a:off x="6233160" y="3977639"/>
+            <a:ext cx="4267200" cy="2057400"/>
+          </a:xfrm>
+          <a:prstGeom prst="rect">
+            <a:avLst/>
+          </a:prstGeom>
+        </p:spPr>
+      </p:pic>
+      <p:sp>
+        <p:nvSpPr>
+          <p:cNvPr id="20" name="TextBox 19"/>
+          <p:cNvSpPr txBox="1"/>
+          <p:nvPr/>
+        </p:nvSpPr>
+        <p:spPr>
+          <a:xfrm>
+            <a:off x="5029200" y="6080759"/>
+            <a:ext cx="6675120" cy="274320"/>
+          </a:xfrm>
+          <a:prstGeom prst="rect">
+            <a:avLst/>
+          </a:prstGeom>
+          <a:noFill/>
+        </p:spPr>
+        <p:txBody>
+          <a:bodyPr wrap="square">
+            <a:spAutoFit/>
+          </a:bodyPr>
+          <a:lstStyle/>
+          <a:p>
+            <a:pPr>
+              <a:spcAft>
+                <a:spcPts val="500"/>
+              </a:spcAft>
+            </a:pPr>
+            <a:r>
+              <a:rPr sz="1100" b="0" i="1">
+                <a:solidFill>
+                  <a:srgbClr val="404040"/>
+                </a:solidFill>
+                <a:latin typeface="Arial"/>
+              </a:rPr>
+              <a:t>Mode chip: pick Interactive</a:t>
+            </a:r>
+          </a:p>
+        </p:txBody>
+      </p:sp>
+    </p:spTree>
+  </p:cSld>
+  <p:clrMapOvr>
+    <a:masterClrMapping/>
+  </p:clrMapOvr>
+</p:sld>
+</file>
+
+<file path=ppt/slides/slide4.xml><?xml version="1.0" encoding="utf-8"?>
+<p:sld xmlns:a="http://schemas.openxmlformats.org/drawingml/2006/main" xmlns:p="http://schemas.openxmlformats.org/presentationml/2006/main" xmlns:r="http://schemas.openxmlformats.org/officeDocument/2006/relationships">
+  <p:cSld>
+    <p:spTree>
+      <p:nvGrpSpPr>
+        <p:cNvPr id="1" name=""/>
+        <p:cNvGrpSpPr/>
+        <p:nvPr/>
+      </p:nvGrpSpPr>
+      <p:grpSpPr/>
+      <p:sp>
+        <p:nvSpPr>
+          <p:cNvPr id="2" name="Rectangle 1"/>
+          <p:cNvSpPr/>
+          <p:nvPr/>
+        </p:nvSpPr>
+        <p:spPr>
+          <a:xfrm>
+            <a:off x="0" y="0"/>
+            <a:ext cx="12191695" cy="109728"/>
+          </a:xfrm>
+          <a:prstGeom prst="rect">
+            <a:avLst/>
+          </a:prstGeom>
+          <a:solidFill>
+            <a:srgbClr val="1F3864"/>
+          </a:solidFill>
+          <a:ln>
+            <a:noFill/>
+          </a:ln>
+          <a:effectLst/>
+        </p:spPr>
+        <p:style>
+          <a:lnRef idx="1">
+            <a:schemeClr val="accent1"/>
+          </a:lnRef>
+          <a:fillRef idx="3">
+            <a:schemeClr val="accent1"/>
+          </a:fillRef>
+          <a:effectRef idx="2">
+            <a:schemeClr val="accent1"/>
+          </a:effectRef>
+          <a:fontRef idx="minor">
+            <a:schemeClr val="lt1"/>
+          </a:fontRef>
+        </p:style>
+        <p:txBody>
+          <a:bodyPr rtlCol="0" anchor="ctr"/>
+          <a:lstStyle/>
+          <a:p>
+            <a:pPr algn="ctr"/>
+          </a:p>
+        </p:txBody>
+      </p:sp>
+      <p:sp>
+        <p:nvSpPr>
+          <p:cNvPr id="3" name="TextBox 2"/>
+          <p:cNvSpPr txBox="1"/>
+          <p:nvPr/>
+        </p:nvSpPr>
+        <p:spPr>
+          <a:xfrm>
+            <a:off x="548640" y="274320"/>
+            <a:ext cx="10972800" cy="320040"/>
+          </a:xfrm>
+          <a:prstGeom prst="rect">
+            <a:avLst/>
+          </a:prstGeom>
+          <a:noFill/>
+        </p:spPr>
+        <p:txBody>
+          <a:bodyPr wrap="square">
+            <a:spAutoFit/>
+          </a:bodyPr>
+          <a:lstStyle/>
+          <a:p>
+            <a:pPr>
+              <a:spcAft>
+                <a:spcPts val="500"/>
+              </a:spcAft>
+            </a:pPr>
+            <a:r>
+              <a:rPr sz="1200" b="1" i="0">
+                <a:solidFill>
+                  <a:srgbClr val="C9A227"/>
+                </a:solidFill>
+                <a:latin typeface="Arial"/>
+              </a:rPr>
+              <a:t>EXAMPLE 1 · CLAUDE OPUS · INTERACTIVE</a:t>
+            </a:r>
+          </a:p>
+        </p:txBody>
+      </p:sp>
+      <p:sp>
+        <p:nvSpPr>
+          <p:cNvPr id="4" name="TextBox 3"/>
+          <p:cNvSpPr txBox="1"/>
+          <p:nvPr/>
+        </p:nvSpPr>
+        <p:spPr>
+          <a:xfrm>
+            <a:off x="548640" y="548640"/>
+            <a:ext cx="10972800" cy="640080"/>
+          </a:xfrm>
+          <a:prstGeom prst="rect">
+            <a:avLst/>
+          </a:prstGeom>
+          <a:noFill/>
+        </p:spPr>
+        <p:txBody>
+          <a:bodyPr wrap="square">
+            <a:spAutoFit/>
+          </a:bodyPr>
+          <a:lstStyle/>
+          <a:p>
+            <a:pPr>
+              <a:spcAft>
+                <a:spcPts val="500"/>
+              </a:spcAft>
+            </a:pPr>
+            <a:r>
+              <a:rPr sz="2800" b="1" i="0">
+                <a:solidFill>
+                  <a:srgbClr val="1F3864"/>
+                </a:solidFill>
+                <a:latin typeface="Arial"/>
+              </a:rPr>
+              <a:t>Excise diagnostic for Indonesia</a:t>
+            </a:r>
+          </a:p>
+        </p:txBody>
+      </p:sp>
+      <p:sp>
+        <p:nvSpPr>
+          <p:cNvPr id="5" name="TextBox 4"/>
+          <p:cNvSpPr txBox="1"/>
+          <p:nvPr/>
+        </p:nvSpPr>
+        <p:spPr>
+          <a:xfrm>
+            <a:off x="548640" y="6446520"/>
+            <a:ext cx="11155680" cy="274320"/>
+          </a:xfrm>
+          <a:prstGeom prst="rect">
+            <a:avLst/>
+          </a:prstGeom>
+          <a:noFill/>
+        </p:spPr>
+        <p:txBody>
+          <a:bodyPr wrap="square">
+            <a:spAutoFit/>
+          </a:bodyPr>
+          <a:lstStyle/>
+          <a:p>
+            <a:pPr>
+              <a:spcAft>
+                <a:spcPts val="500"/>
+              </a:spcAft>
+            </a:pPr>
+            <a:r>
+              <a:rPr sz="900" b="0" i="0">
+                <a:solidFill>
+                  <a:srgbClr val="808080"/>
+                </a:solidFill>
+                <a:latin typeface="Arial"/>
+              </a:rPr>
+              <a:t>AI Tools Quick Start  ·  GitHub Copilot app  ·  October 2026  ·  Screens change over time</a:t>
+            </a:r>
+          </a:p>
+        </p:txBody>
+      </p:sp>
+      <p:sp>
+        <p:nvSpPr>
+          <p:cNvPr id="6" name="Rectangle 5"/>
+          <p:cNvSpPr/>
+          <p:nvPr/>
+        </p:nvSpPr>
+        <p:spPr>
+          <a:xfrm>
+            <a:off x="548640" y="1325880"/>
+            <a:ext cx="6583680" cy="868680"/>
+          </a:xfrm>
+          <a:prstGeom prst="rect">
+            <a:avLst/>
+          </a:prstGeom>
+          <a:solidFill>
+            <a:srgbClr val="FDECEA"/>
+          </a:solidFill>
+          <a:ln>
+            <a:noFill/>
+          </a:ln>
+          <a:effectLst/>
+        </p:spPr>
+        <p:style>
+          <a:lnRef idx="1">
+            <a:schemeClr val="accent1"/>
+          </a:lnRef>
+          <a:fillRef idx="3">
+            <a:schemeClr val="accent1"/>
+          </a:fillRef>
+          <a:effectRef idx="2">
+            <a:schemeClr val="accent1"/>
+          </a:effectRef>
+          <a:fontRef idx="minor">
+            <a:schemeClr val="lt1"/>
+          </a:fontRef>
+        </p:style>
+        <p:txBody>
+          <a:bodyPr rtlCol="0" anchor="ctr"/>
+          <a:lstStyle/>
+          <a:p>
+            <a:pPr algn="ctr"/>
+          </a:p>
+        </p:txBody>
+      </p:sp>
+      <p:sp>
+        <p:nvSpPr>
+          <p:cNvPr id="7" name="Rectangle 6"/>
+          <p:cNvSpPr/>
+          <p:nvPr/>
+        </p:nvSpPr>
+        <p:spPr>
+          <a:xfrm>
+            <a:off x="548640" y="1325880"/>
+            <a:ext cx="73152" cy="868680"/>
+          </a:xfrm>
+          <a:prstGeom prst="rect">
+            <a:avLst/>
+          </a:prstGeom>
+          <a:solidFill>
+            <a:srgbClr val="C0392B"/>
+          </a:solidFill>
+          <a:ln>
+            <a:noFill/>
+          </a:ln>
+          <a:effectLst/>
+        </p:spPr>
+        <p:style>
+          <a:lnRef idx="1">
+            <a:schemeClr val="accent1"/>
+          </a:lnRef>
+          <a:fillRef idx="3">
+            <a:schemeClr val="accent1"/>
+          </a:fillRef>
+          <a:effectRef idx="2">
+            <a:schemeClr val="accent1"/>
+          </a:effectRef>
+          <a:fontRef idx="minor">
+            <a:schemeClr val="lt1"/>
+          </a:fontRef>
+        </p:style>
+        <p:txBody>
+          <a:bodyPr rtlCol="0" anchor="ctr"/>
+          <a:lstStyle/>
+          <a:p>
+            <a:pPr algn="ctr"/>
+          </a:p>
+        </p:txBody>
+      </p:sp>
+      <p:sp>
+        <p:nvSpPr>
+          <p:cNvPr id="8" name="TextBox 7"/>
+          <p:cNvSpPr txBox="1"/>
+          <p:nvPr/>
+        </p:nvSpPr>
+        <p:spPr>
+          <a:xfrm>
+            <a:off x="731520" y="1371600"/>
+            <a:ext cx="6309360" cy="822960"/>
+          </a:xfrm>
+          <a:prstGeom prst="rect">
+            <a:avLst/>
+          </a:prstGeom>
+          <a:noFill/>
+        </p:spPr>
+        <p:txBody>
+          <a:bodyPr wrap="square">
+            <a:spAutoFit/>
+          </a:bodyPr>
+          <a:lstStyle/>
+          <a:p>
+            <a:pPr>
+              <a:spcAft>
+                <a:spcPts val="500"/>
+              </a:spcAft>
+            </a:pPr>
+            <a:r>
+              <a:rPr sz="1200" b="1" i="0">
+                <a:solidFill>
+                  <a:srgbClr val="C0392B"/>
+                </a:solidFill>
+                <a:latin typeface="Arial"/>
+              </a:rPr>
+              <a:t>⚠  Deep research uses a lot of credits. Send one prompt, read the answer, then send the next. Check /context as you go. Stop and fix anything wrong before going on.</a:t>
+            </a:r>
+          </a:p>
+        </p:txBody>
+      </p:sp>
+      <p:sp>
+        <p:nvSpPr>
+          <p:cNvPr id="9" name="TextBox 8"/>
+          <p:cNvSpPr txBox="1"/>
+          <p:nvPr/>
+        </p:nvSpPr>
+        <p:spPr>
+          <a:xfrm>
+            <a:off x="548640" y="2331720"/>
+            <a:ext cx="6583680" cy="457200"/>
+          </a:xfrm>
+          <a:prstGeom prst="rect">
+            <a:avLst/>
+          </a:prstGeom>
+          <a:noFill/>
+        </p:spPr>
+        <p:txBody>
+          <a:bodyPr wrap="square">
+            <a:spAutoFit/>
+          </a:bodyPr>
+          <a:lstStyle/>
+          <a:p>
+            <a:pPr>
+              <a:spcAft>
+                <a:spcPts val="500"/>
+              </a:spcAft>
+            </a:pPr>
+            <a:r>
+              <a:rPr sz="1200" b="0" i="0">
+                <a:solidFill>
+                  <a:srgbClr val="404040"/>
+                </a:solidFill>
+                <a:latin typeface="Arial"/>
+              </a:rPr>
+              <a:t>Attach the instructions: type @ and pick user_guide/excise_diagnostic_process.md (or drag the file onto the prompt box).</a:t>
+            </a:r>
+          </a:p>
+        </p:txBody>
+      </p:sp>
+      <p:sp>
+        <p:nvSpPr>
+          <p:cNvPr id="10" name="TextBox 9"/>
+          <p:cNvSpPr txBox="1"/>
+          <p:nvPr/>
+        </p:nvSpPr>
+        <p:spPr>
+          <a:xfrm>
+            <a:off x="548640" y="2880360"/>
+            <a:ext cx="6583680" cy="274320"/>
+          </a:xfrm>
+          <a:prstGeom prst="rect">
+            <a:avLst/>
+          </a:prstGeom>
+          <a:noFill/>
+        </p:spPr>
+        <p:txBody>
+          <a:bodyPr wrap="square">
+            <a:spAutoFit/>
+          </a:bodyPr>
+          <a:lstStyle/>
+          <a:p>
+            <a:pPr>
+              <a:spcAft>
+                <a:spcPts val="500"/>
+              </a:spcAft>
+            </a:pPr>
+            <a:r>
+              <a:rPr sz="1300" b="1" i="0">
                 <a:solidFill>
                   <a:srgbClr val="1F3864"/>
                 </a:solidFill>
@@ -4514,14 +5511,14 @@
       </p:sp>
       <p:sp>
         <p:nvSpPr>
-          <p:cNvPr id="6" name="Rectangle 5"/>
+          <p:cNvPr id="11" name="Rectangle 10"/>
           <p:cNvSpPr/>
           <p:nvPr/>
         </p:nvSpPr>
         <p:spPr>
           <a:xfrm>
-            <a:off x="640080" y="2194560"/>
-            <a:ext cx="10972800" cy="960120"/>
+            <a:off x="548640" y="3200400"/>
+            <a:ext cx="6583680" cy="868680"/>
           </a:xfrm>
           <a:prstGeom prst="rect">
             <a:avLst/>
@@ -4558,14 +5555,14 @@
       </p:sp>
       <p:sp>
         <p:nvSpPr>
-          <p:cNvPr id="7" name="TextBox 6"/>
+          <p:cNvPr id="12" name="TextBox 11"/>
           <p:cNvSpPr txBox="1"/>
           <p:nvPr/>
         </p:nvSpPr>
         <p:spPr>
           <a:xfrm>
-            <a:off x="777240" y="2240279"/>
-            <a:ext cx="10698480" cy="960120"/>
+            <a:off x="640080" y="3227832"/>
+            <a:ext cx="6400800" cy="868680"/>
           </a:xfrm>
           <a:prstGeom prst="rect">
             <a:avLst/>
@@ -4580,31 +5577,31 @@
           <a:p>
             <a:pPr>
               <a:spcAft>
-                <a:spcPts val="600"/>
+                <a:spcPts val="500"/>
               </a:spcAft>
             </a:pPr>
             <a:r>
-              <a:rPr sz="1500" b="0">
+              <a:rPr sz="1200" b="0" i="0">
                 <a:solidFill>
                   <a:srgbClr val="262626"/>
                 </a:solidFill>
                 <a:latin typeface="Consolas"/>
               </a:rPr>
-              <a:t>Add VAT, personal income tax, corporate income tax and excises (% of GDP) to the dashboard, under Tax revenue, from the IMF WoRLD file already in raw_data. Follow TaxMacroFiscalDashboard/build/README.md. Then rebuild and show me Indonesia.</a:t>
-            </a:r>
-          </a:p>
-        </p:txBody>
-      </p:sp>
-      <p:sp>
-        <p:nvSpPr>
-          <p:cNvPr id="8" name="TextBox 7"/>
+              <a:t>@user_guide/excise_diagnostic_process.md Follow this file. Run stage A1 for Indonesia, 2020 to 2026-09-30. Search the web for the laws. Stop after A1.</a:t>
+            </a:r>
+          </a:p>
+        </p:txBody>
+      </p:sp>
+      <p:sp>
+        <p:nvSpPr>
+          <p:cNvPr id="13" name="TextBox 12"/>
           <p:cNvSpPr txBox="1"/>
           <p:nvPr/>
         </p:nvSpPr>
         <p:spPr>
           <a:xfrm>
-            <a:off x="640080" y="3429000"/>
-            <a:ext cx="10972800" cy="365760"/>
+            <a:off x="548640" y="4206240"/>
+            <a:ext cx="6583680" cy="274320"/>
           </a:xfrm>
           <a:prstGeom prst="rect">
             <a:avLst/>
@@ -4619,31 +5616,31 @@
           <a:p>
             <a:pPr>
               <a:spcAft>
-                <a:spcPts val="600"/>
+                <a:spcPts val="500"/>
               </a:spcAft>
             </a:pPr>
             <a:r>
-              <a:rPr sz="1400" b="1">
+              <a:rPr sz="1300" b="1" i="0">
                 <a:solidFill>
                   <a:srgbClr val="1F3864"/>
                 </a:solidFill>
                 <a:latin typeface="Arial"/>
               </a:rPr>
-              <a:t>Then:</a:t>
-            </a:r>
-          </a:p>
-        </p:txBody>
-      </p:sp>
-      <p:sp>
-        <p:nvSpPr>
-          <p:cNvPr id="9" name="Rectangle 8"/>
+              <a:t>Then, one at a time:</a:t>
+            </a:r>
+          </a:p>
+        </p:txBody>
+      </p:sp>
+      <p:sp>
+        <p:nvSpPr>
+          <p:cNvPr id="14" name="Rectangle 13"/>
           <p:cNvSpPr/>
           <p:nvPr/>
         </p:nvSpPr>
         <p:spPr>
           <a:xfrm>
-            <a:off x="640080" y="3840480"/>
-            <a:ext cx="10972800" cy="384048"/>
+            <a:off x="548640" y="4526279"/>
+            <a:ext cx="6583680" cy="329184"/>
           </a:xfrm>
           <a:prstGeom prst="rect">
             <a:avLst/>
@@ -4680,14 +5677,14 @@
       </p:sp>
       <p:sp>
         <p:nvSpPr>
-          <p:cNvPr id="10" name="TextBox 9"/>
+          <p:cNvPr id="15" name="TextBox 14"/>
           <p:cNvSpPr txBox="1"/>
           <p:nvPr/>
         </p:nvSpPr>
         <p:spPr>
           <a:xfrm>
-            <a:off x="777240" y="3849624"/>
-            <a:ext cx="10698480" cy="384048"/>
+            <a:off x="640080" y="4553712"/>
+            <a:ext cx="6400800" cy="329184"/>
           </a:xfrm>
           <a:prstGeom prst="rect">
             <a:avLst/>
@@ -4702,31 +5699,470 @@
           <a:p>
             <a:pPr>
               <a:spcAft>
-                <a:spcPts val="600"/>
+                <a:spcPts val="500"/>
               </a:spcAft>
             </a:pPr>
             <a:r>
-              <a:rPr sz="1300" b="0">
+              <a:rPr sz="1100" b="0" i="0">
                 <a:solidFill>
                   <a:srgbClr val="262626"/>
                 </a:solidFill>
                 <a:latin typeface="Consolas"/>
               </a:rPr>
-              <a:t>Commit and push.</a:t>
-            </a:r>
-          </a:p>
-        </p:txBody>
-      </p:sp>
-      <p:sp>
-        <p:nvSpPr>
-          <p:cNvPr id="11" name="Rectangle 10"/>
+              <a:t>Run stage A2.</a:t>
+            </a:r>
+          </a:p>
+        </p:txBody>
+      </p:sp>
+      <p:sp>
+        <p:nvSpPr>
+          <p:cNvPr id="16" name="Rectangle 15"/>
           <p:cNvSpPr/>
           <p:nvPr/>
         </p:nvSpPr>
         <p:spPr>
           <a:xfrm>
-            <a:off x="640080" y="5120640"/>
-            <a:ext cx="10972800" cy="548640"/>
+            <a:off x="548640" y="4919471"/>
+            <a:ext cx="6583680" cy="329184"/>
+          </a:xfrm>
+          <a:prstGeom prst="rect">
+            <a:avLst/>
+          </a:prstGeom>
+          <a:solidFill>
+            <a:srgbClr val="F2F2F2"/>
+          </a:solidFill>
+          <a:ln>
+            <a:noFill/>
+          </a:ln>
+          <a:effectLst/>
+        </p:spPr>
+        <p:style>
+          <a:lnRef idx="1">
+            <a:schemeClr val="accent1"/>
+          </a:lnRef>
+          <a:fillRef idx="3">
+            <a:schemeClr val="accent1"/>
+          </a:fillRef>
+          <a:effectRef idx="2">
+            <a:schemeClr val="accent1"/>
+          </a:effectRef>
+          <a:fontRef idx="minor">
+            <a:schemeClr val="lt1"/>
+          </a:fontRef>
+        </p:style>
+        <p:txBody>
+          <a:bodyPr rtlCol="0" anchor="ctr"/>
+          <a:lstStyle/>
+          <a:p>
+            <a:pPr algn="ctr"/>
+          </a:p>
+        </p:txBody>
+      </p:sp>
+      <p:sp>
+        <p:nvSpPr>
+          <p:cNvPr id="17" name="TextBox 16"/>
+          <p:cNvSpPr txBox="1"/>
+          <p:nvPr/>
+        </p:nvSpPr>
+        <p:spPr>
+          <a:xfrm>
+            <a:off x="640080" y="4946903"/>
+            <a:ext cx="6400800" cy="329184"/>
+          </a:xfrm>
+          <a:prstGeom prst="rect">
+            <a:avLst/>
+          </a:prstGeom>
+          <a:noFill/>
+        </p:spPr>
+        <p:txBody>
+          <a:bodyPr wrap="square">
+            <a:spAutoFit/>
+          </a:bodyPr>
+          <a:lstStyle/>
+          <a:p>
+            <a:pPr>
+              <a:spcAft>
+                <a:spcPts val="500"/>
+              </a:spcAft>
+            </a:pPr>
+            <a:r>
+              <a:rPr sz="1100" b="0" i="0">
+                <a:solidFill>
+                  <a:srgbClr val="262626"/>
+                </a:solidFill>
+                <a:latin typeface="Consolas"/>
+              </a:rPr>
+              <a:t>Run stage A3.</a:t>
+            </a:r>
+          </a:p>
+        </p:txBody>
+      </p:sp>
+      <p:sp>
+        <p:nvSpPr>
+          <p:cNvPr id="18" name="Rectangle 17"/>
+          <p:cNvSpPr/>
+          <p:nvPr/>
+        </p:nvSpPr>
+        <p:spPr>
+          <a:xfrm>
+            <a:off x="548640" y="5312663"/>
+            <a:ext cx="6583680" cy="329184"/>
+          </a:xfrm>
+          <a:prstGeom prst="rect">
+            <a:avLst/>
+          </a:prstGeom>
+          <a:solidFill>
+            <a:srgbClr val="F2F2F2"/>
+          </a:solidFill>
+          <a:ln>
+            <a:noFill/>
+          </a:ln>
+          <a:effectLst/>
+        </p:spPr>
+        <p:style>
+          <a:lnRef idx="1">
+            <a:schemeClr val="accent1"/>
+          </a:lnRef>
+          <a:fillRef idx="3">
+            <a:schemeClr val="accent1"/>
+          </a:fillRef>
+          <a:effectRef idx="2">
+            <a:schemeClr val="accent1"/>
+          </a:effectRef>
+          <a:fontRef idx="minor">
+            <a:schemeClr val="lt1"/>
+          </a:fontRef>
+        </p:style>
+        <p:txBody>
+          <a:bodyPr rtlCol="0" anchor="ctr"/>
+          <a:lstStyle/>
+          <a:p>
+            <a:pPr algn="ctr"/>
+          </a:p>
+        </p:txBody>
+      </p:sp>
+      <p:sp>
+        <p:nvSpPr>
+          <p:cNvPr id="19" name="TextBox 18"/>
+          <p:cNvSpPr txBox="1"/>
+          <p:nvPr/>
+        </p:nvSpPr>
+        <p:spPr>
+          <a:xfrm>
+            <a:off x="640080" y="5340095"/>
+            <a:ext cx="6400800" cy="329184"/>
+          </a:xfrm>
+          <a:prstGeom prst="rect">
+            <a:avLst/>
+          </a:prstGeom>
+          <a:noFill/>
+        </p:spPr>
+        <p:txBody>
+          <a:bodyPr wrap="square">
+            <a:spAutoFit/>
+          </a:bodyPr>
+          <a:lstStyle/>
+          <a:p>
+            <a:pPr>
+              <a:spcAft>
+                <a:spcPts val="500"/>
+              </a:spcAft>
+            </a:pPr>
+            <a:r>
+              <a:rPr sz="1100" b="0" i="0">
+                <a:solidFill>
+                  <a:srgbClr val="262626"/>
+                </a:solidFill>
+                <a:latin typeface="Consolas"/>
+              </a:rPr>
+              <a:t>Run stage A4.</a:t>
+            </a:r>
+          </a:p>
+        </p:txBody>
+      </p:sp>
+      <p:sp>
+        <p:nvSpPr>
+          <p:cNvPr id="20" name="Rectangle 19"/>
+          <p:cNvSpPr/>
+          <p:nvPr/>
+        </p:nvSpPr>
+        <p:spPr>
+          <a:xfrm>
+            <a:off x="548640" y="5705855"/>
+            <a:ext cx="6583680" cy="329184"/>
+          </a:xfrm>
+          <a:prstGeom prst="rect">
+            <a:avLst/>
+          </a:prstGeom>
+          <a:solidFill>
+            <a:srgbClr val="F2F2F2"/>
+          </a:solidFill>
+          <a:ln>
+            <a:noFill/>
+          </a:ln>
+          <a:effectLst/>
+        </p:spPr>
+        <p:style>
+          <a:lnRef idx="1">
+            <a:schemeClr val="accent1"/>
+          </a:lnRef>
+          <a:fillRef idx="3">
+            <a:schemeClr val="accent1"/>
+          </a:fillRef>
+          <a:effectRef idx="2">
+            <a:schemeClr val="accent1"/>
+          </a:effectRef>
+          <a:fontRef idx="minor">
+            <a:schemeClr val="lt1"/>
+          </a:fontRef>
+        </p:style>
+        <p:txBody>
+          <a:bodyPr rtlCol="0" anchor="ctr"/>
+          <a:lstStyle/>
+          <a:p>
+            <a:pPr algn="ctr"/>
+          </a:p>
+        </p:txBody>
+      </p:sp>
+      <p:sp>
+        <p:nvSpPr>
+          <p:cNvPr id="21" name="TextBox 20"/>
+          <p:cNvSpPr txBox="1"/>
+          <p:nvPr/>
+        </p:nvSpPr>
+        <p:spPr>
+          <a:xfrm>
+            <a:off x="640080" y="5733287"/>
+            <a:ext cx="6400800" cy="329184"/>
+          </a:xfrm>
+          <a:prstGeom prst="rect">
+            <a:avLst/>
+          </a:prstGeom>
+          <a:noFill/>
+        </p:spPr>
+        <p:txBody>
+          <a:bodyPr wrap="square">
+            <a:spAutoFit/>
+          </a:bodyPr>
+          <a:lstStyle/>
+          <a:p>
+            <a:pPr>
+              <a:spcAft>
+                <a:spcPts val="500"/>
+              </a:spcAft>
+            </a:pPr>
+            <a:r>
+              <a:rPr sz="1100" b="0" i="0">
+                <a:solidFill>
+                  <a:srgbClr val="262626"/>
+                </a:solidFill>
+                <a:latin typeface="Consolas"/>
+              </a:rPr>
+              <a:t>Run stage A5.</a:t>
+            </a:r>
+          </a:p>
+        </p:txBody>
+      </p:sp>
+      <p:sp>
+        <p:nvSpPr>
+          <p:cNvPr id="22" name="Rectangle 21"/>
+          <p:cNvSpPr/>
+          <p:nvPr/>
+        </p:nvSpPr>
+        <p:spPr>
+          <a:xfrm>
+            <a:off x="548640" y="6099047"/>
+            <a:ext cx="6583680" cy="548640"/>
+          </a:xfrm>
+          <a:prstGeom prst="rect">
+            <a:avLst/>
+          </a:prstGeom>
+          <a:solidFill>
+            <a:srgbClr val="F2F2F2"/>
+          </a:solidFill>
+          <a:ln>
+            <a:noFill/>
+          </a:ln>
+          <a:effectLst/>
+        </p:spPr>
+        <p:style>
+          <a:lnRef idx="1">
+            <a:schemeClr val="accent1"/>
+          </a:lnRef>
+          <a:fillRef idx="3">
+            <a:schemeClr val="accent1"/>
+          </a:fillRef>
+          <a:effectRef idx="2">
+            <a:schemeClr val="accent1"/>
+          </a:effectRef>
+          <a:fontRef idx="minor">
+            <a:schemeClr val="lt1"/>
+          </a:fontRef>
+        </p:style>
+        <p:txBody>
+          <a:bodyPr rtlCol="0" anchor="ctr"/>
+          <a:lstStyle/>
+          <a:p>
+            <a:pPr algn="ctr"/>
+          </a:p>
+        </p:txBody>
+      </p:sp>
+      <p:sp>
+        <p:nvSpPr>
+          <p:cNvPr id="23" name="TextBox 22"/>
+          <p:cNvSpPr txBox="1"/>
+          <p:nvPr/>
+        </p:nvSpPr>
+        <p:spPr>
+          <a:xfrm>
+            <a:off x="640080" y="6126479"/>
+            <a:ext cx="6400800" cy="548640"/>
+          </a:xfrm>
+          <a:prstGeom prst="rect">
+            <a:avLst/>
+          </a:prstGeom>
+          <a:noFill/>
+        </p:spPr>
+        <p:txBody>
+          <a:bodyPr wrap="square">
+            <a:spAutoFit/>
+          </a:bodyPr>
+          <a:lstStyle/>
+          <a:p>
+            <a:pPr>
+              <a:spcAft>
+                <a:spcPts val="500"/>
+              </a:spcAft>
+            </a:pPr>
+            <a:r>
+              <a:rPr sz="1100" b="0" i="0">
+                <a:solidFill>
+                  <a:srgbClr val="262626"/>
+                </a:solidFill>
+                <a:latin typeface="Consolas"/>
+              </a:rPr>
+              <a:t>Run stage A6. Save the Word report and Excel workbook in ExciseDiagnostic/country_results/Indonesia/.</a:t>
+            </a:r>
+          </a:p>
+        </p:txBody>
+      </p:sp>
+      <p:sp>
+        <p:nvSpPr>
+          <p:cNvPr id="24" name="Rectangle 23"/>
+          <p:cNvSpPr/>
+          <p:nvPr/>
+        </p:nvSpPr>
+        <p:spPr>
+          <a:xfrm>
+            <a:off x="7379208" y="1344168"/>
+            <a:ext cx="4352544" cy="2472309"/>
+          </a:xfrm>
+          <a:prstGeom prst="rect">
+            <a:avLst/>
+          </a:prstGeom>
+          <a:solidFill>
+            <a:srgbClr val="BFBFBF"/>
+          </a:solidFill>
+          <a:ln>
+            <a:noFill/>
+          </a:ln>
+          <a:effectLst/>
+        </p:spPr>
+        <p:style>
+          <a:lnRef idx="1">
+            <a:schemeClr val="accent1"/>
+          </a:lnRef>
+          <a:fillRef idx="3">
+            <a:schemeClr val="accent1"/>
+          </a:fillRef>
+          <a:effectRef idx="2">
+            <a:schemeClr val="accent1"/>
+          </a:effectRef>
+          <a:fontRef idx="minor">
+            <a:schemeClr val="lt1"/>
+          </a:fontRef>
+        </p:style>
+        <p:txBody>
+          <a:bodyPr rtlCol="0" anchor="ctr"/>
+          <a:lstStyle/>
+          <a:p>
+            <a:pPr algn="ctr"/>
+          </a:p>
+        </p:txBody>
+      </p:sp>
+      <p:pic>
+        <p:nvPicPr>
+          <p:cNvPr id="25" name="Picture 24" descr="s_working.png"/>
+          <p:cNvPicPr>
+            <a:picLocks noChangeAspect="1"/>
+          </p:cNvPicPr>
+          <p:nvPr/>
+        </p:nvPicPr>
+        <p:blipFill>
+          <a:blip r:embed="rId2"/>
+          <a:stretch>
+            <a:fillRect/>
+          </a:stretch>
+        </p:blipFill>
+        <p:spPr>
+          <a:xfrm>
+            <a:off x="7406640" y="1371600"/>
+            <a:ext cx="4297680" cy="2417445"/>
+          </a:xfrm>
+          <a:prstGeom prst="rect">
+            <a:avLst/>
+          </a:prstGeom>
+        </p:spPr>
+      </p:pic>
+      <p:sp>
+        <p:nvSpPr>
+          <p:cNvPr id="26" name="TextBox 25"/>
+          <p:cNvSpPr txBox="1"/>
+          <p:nvPr/>
+        </p:nvSpPr>
+        <p:spPr>
+          <a:xfrm>
+            <a:off x="7406640" y="3834765"/>
+            <a:ext cx="4297680" cy="274320"/>
+          </a:xfrm>
+          <a:prstGeom prst="rect">
+            <a:avLst/>
+          </a:prstGeom>
+          <a:noFill/>
+        </p:spPr>
+        <p:txBody>
+          <a:bodyPr wrap="square">
+            <a:spAutoFit/>
+          </a:bodyPr>
+          <a:lstStyle/>
+          <a:p>
+            <a:pPr>
+              <a:spcAft>
+                <a:spcPts val="500"/>
+              </a:spcAft>
+            </a:pPr>
+            <a:r>
+              <a:rPr sz="1100" b="0" i="1">
+                <a:solidFill>
+                  <a:srgbClr val="404040"/>
+                </a:solidFill>
+                <a:latin typeface="Arial"/>
+              </a:rPr>
+              <a:t>A session at work: the steps on the left, the plan on the right</a:t>
+            </a:r>
+          </a:p>
+        </p:txBody>
+      </p:sp>
+      <p:sp>
+        <p:nvSpPr>
+          <p:cNvPr id="27" name="Rectangle 26"/>
+          <p:cNvSpPr/>
+          <p:nvPr/>
+        </p:nvSpPr>
+        <p:spPr>
+          <a:xfrm>
+            <a:off x="7406640" y="5212080"/>
+            <a:ext cx="4297680" cy="914400"/>
           </a:xfrm>
           <a:prstGeom prst="rect">
             <a:avLst/>
@@ -4763,14 +6199,58 @@
       </p:sp>
       <p:sp>
         <p:nvSpPr>
-          <p:cNvPr id="12" name="TextBox 11"/>
+          <p:cNvPr id="28" name="Rectangle 27"/>
+          <p:cNvSpPr/>
+          <p:nvPr/>
+        </p:nvSpPr>
+        <p:spPr>
+          <a:xfrm>
+            <a:off x="7406640" y="5212080"/>
+            <a:ext cx="73152" cy="914400"/>
+          </a:xfrm>
+          <a:prstGeom prst="rect">
+            <a:avLst/>
+          </a:prstGeom>
+          <a:solidFill>
+            <a:srgbClr val="C9A227"/>
+          </a:solidFill>
+          <a:ln>
+            <a:noFill/>
+          </a:ln>
+          <a:effectLst/>
+        </p:spPr>
+        <p:style>
+          <a:lnRef idx="1">
+            <a:schemeClr val="accent1"/>
+          </a:lnRef>
+          <a:fillRef idx="3">
+            <a:schemeClr val="accent1"/>
+          </a:fillRef>
+          <a:effectRef idx="2">
+            <a:schemeClr val="accent1"/>
+          </a:effectRef>
+          <a:fontRef idx="minor">
+            <a:schemeClr val="lt1"/>
+          </a:fontRef>
+        </p:style>
+        <p:txBody>
+          <a:bodyPr rtlCol="0" anchor="ctr"/>
+          <a:lstStyle/>
+          <a:p>
+            <a:pPr algn="ctr"/>
+          </a:p>
+        </p:txBody>
+      </p:sp>
+      <p:sp>
+        <p:nvSpPr>
+          <p:cNvPr id="29" name="TextBox 28"/>
           <p:cNvSpPr txBox="1"/>
           <p:nvPr/>
         </p:nvSpPr>
         <p:spPr>
           <a:xfrm>
-            <a:off x="777240" y="5184648"/>
-            <a:ext cx="10698480" cy="457200"/>
+            <a:off x="7589520" y="5257800"/>
+            <a:ext cx="4023360" cy="868680"/>
           </a:xfrm>
           <a:prstGeom prst="rect">
             <a:avLst/>
@@ -4785,17 +6265,1451 @@
           <a:p>
             <a:pPr>
               <a:spcAft>
-                <a:spcPts val="600"/>
+                <a:spcPts val="500"/>
               </a:spcAft>
             </a:pPr>
             <a:r>
-              <a:rPr sz="1500" b="1">
+              <a:rPr sz="1200" b="1" i="0">
+                <a:solidFill>
+                  <a:srgbClr val="1F3864"/>
+                </a:solidFill>
+                <a:latin typeface="Arial"/>
+              </a:rPr>
+              <a:t>Check: Every rate quoted with its date and a source link; missing data says data_gap.</a:t>
+            </a:r>
+          </a:p>
+        </p:txBody>
+      </p:sp>
+    </p:spTree>
+  </p:cSld>
+  <p:clrMapOvr>
+    <a:masterClrMapping/>
+  </p:clrMapOvr>
+</p:sld>
+</file>
+
+<file path=ppt/slides/slide5.xml><?xml version="1.0" encoding="utf-8"?>
+<p:sld xmlns:a="http://schemas.openxmlformats.org/drawingml/2006/main" xmlns:p="http://schemas.openxmlformats.org/presentationml/2006/main" xmlns:r="http://schemas.openxmlformats.org/officeDocument/2006/relationships">
+  <p:cSld>
+    <p:spTree>
+      <p:nvGrpSpPr>
+        <p:cNvPr id="1" name=""/>
+        <p:cNvGrpSpPr/>
+        <p:nvPr/>
+      </p:nvGrpSpPr>
+      <p:grpSpPr/>
+      <p:sp>
+        <p:nvSpPr>
+          <p:cNvPr id="2" name="Rectangle 1"/>
+          <p:cNvSpPr/>
+          <p:nvPr/>
+        </p:nvSpPr>
+        <p:spPr>
+          <a:xfrm>
+            <a:off x="0" y="0"/>
+            <a:ext cx="12191695" cy="109728"/>
+          </a:xfrm>
+          <a:prstGeom prst="rect">
+            <a:avLst/>
+          </a:prstGeom>
+          <a:solidFill>
+            <a:srgbClr val="1F3864"/>
+          </a:solidFill>
+          <a:ln>
+            <a:noFill/>
+          </a:ln>
+          <a:effectLst/>
+        </p:spPr>
+        <p:style>
+          <a:lnRef idx="1">
+            <a:schemeClr val="accent1"/>
+          </a:lnRef>
+          <a:fillRef idx="3">
+            <a:schemeClr val="accent1"/>
+          </a:fillRef>
+          <a:effectRef idx="2">
+            <a:schemeClr val="accent1"/>
+          </a:effectRef>
+          <a:fontRef idx="minor">
+            <a:schemeClr val="lt1"/>
+          </a:fontRef>
+        </p:style>
+        <p:txBody>
+          <a:bodyPr rtlCol="0" anchor="ctr"/>
+          <a:lstStyle/>
+          <a:p>
+            <a:pPr algn="ctr"/>
+          </a:p>
+        </p:txBody>
+      </p:sp>
+      <p:sp>
+        <p:nvSpPr>
+          <p:cNvPr id="3" name="TextBox 2"/>
+          <p:cNvSpPr txBox="1"/>
+          <p:nvPr/>
+        </p:nvSpPr>
+        <p:spPr>
+          <a:xfrm>
+            <a:off x="548640" y="274320"/>
+            <a:ext cx="10972800" cy="320040"/>
+          </a:xfrm>
+          <a:prstGeom prst="rect">
+            <a:avLst/>
+          </a:prstGeom>
+          <a:noFill/>
+        </p:spPr>
+        <p:txBody>
+          <a:bodyPr wrap="square">
+            <a:spAutoFit/>
+          </a:bodyPr>
+          <a:lstStyle/>
+          <a:p>
+            <a:pPr>
+              <a:spcAft>
+                <a:spcPts val="500"/>
+              </a:spcAft>
+            </a:pPr>
+            <a:r>
+              <a:rPr sz="1200" b="1" i="0">
+                <a:solidFill>
+                  <a:srgbClr val="C9A227"/>
+                </a:solidFill>
+                <a:latin typeface="Arial"/>
+              </a:rPr>
+              <a:t>EXAMPLE 2 · CLAUDE SONNET · INTERACTIVE</a:t>
+            </a:r>
+          </a:p>
+        </p:txBody>
+      </p:sp>
+      <p:sp>
+        <p:nvSpPr>
+          <p:cNvPr id="4" name="TextBox 3"/>
+          <p:cNvSpPr txBox="1"/>
+          <p:nvPr/>
+        </p:nvSpPr>
+        <p:spPr>
+          <a:xfrm>
+            <a:off x="548640" y="548640"/>
+            <a:ext cx="10972800" cy="640080"/>
+          </a:xfrm>
+          <a:prstGeom prst="rect">
+            <a:avLst/>
+          </a:prstGeom>
+          <a:noFill/>
+        </p:spPr>
+        <p:txBody>
+          <a:bodyPr wrap="square">
+            <a:spAutoFit/>
+          </a:bodyPr>
+          <a:lstStyle/>
+          <a:p>
+            <a:pPr>
+              <a:spcAft>
+                <a:spcPts val="500"/>
+              </a:spcAft>
+            </a:pPr>
+            <a:r>
+              <a:rPr sz="2800" b="1" i="0">
+                <a:solidFill>
+                  <a:srgbClr val="1F3864"/>
+                </a:solidFill>
+                <a:latin typeface="Arial"/>
+              </a:rPr>
+              <a:t>Add tax indicators to the dashboard</a:t>
+            </a:r>
+          </a:p>
+        </p:txBody>
+      </p:sp>
+      <p:sp>
+        <p:nvSpPr>
+          <p:cNvPr id="5" name="TextBox 4"/>
+          <p:cNvSpPr txBox="1"/>
+          <p:nvPr/>
+        </p:nvSpPr>
+        <p:spPr>
+          <a:xfrm>
+            <a:off x="548640" y="6446520"/>
+            <a:ext cx="11155680" cy="274320"/>
+          </a:xfrm>
+          <a:prstGeom prst="rect">
+            <a:avLst/>
+          </a:prstGeom>
+          <a:noFill/>
+        </p:spPr>
+        <p:txBody>
+          <a:bodyPr wrap="square">
+            <a:spAutoFit/>
+          </a:bodyPr>
+          <a:lstStyle/>
+          <a:p>
+            <a:pPr>
+              <a:spcAft>
+                <a:spcPts val="500"/>
+              </a:spcAft>
+            </a:pPr>
+            <a:r>
+              <a:rPr sz="900" b="0" i="0">
+                <a:solidFill>
+                  <a:srgbClr val="808080"/>
+                </a:solidFill>
+                <a:latin typeface="Arial"/>
+              </a:rPr>
+              <a:t>AI Tools Quick Start  ·  GitHub Copilot app  ·  October 2026  ·  Screens change over time</a:t>
+            </a:r>
+          </a:p>
+        </p:txBody>
+      </p:sp>
+      <p:sp>
+        <p:nvSpPr>
+          <p:cNvPr id="6" name="TextBox 5"/>
+          <p:cNvSpPr txBox="1"/>
+          <p:nvPr/>
+        </p:nvSpPr>
+        <p:spPr>
+          <a:xfrm>
+            <a:off x="548640" y="1325880"/>
+            <a:ext cx="6583680" cy="274320"/>
+          </a:xfrm>
+          <a:prstGeom prst="rect">
+            <a:avLst/>
+          </a:prstGeom>
+          <a:noFill/>
+        </p:spPr>
+        <p:txBody>
+          <a:bodyPr wrap="square">
+            <a:spAutoFit/>
+          </a:bodyPr>
+          <a:lstStyle/>
+          <a:p>
+            <a:pPr>
+              <a:spcAft>
+                <a:spcPts val="500"/>
+              </a:spcAft>
+            </a:pPr>
+            <a:r>
+              <a:rPr sz="1300" b="1" i="0">
+                <a:solidFill>
+                  <a:srgbClr val="1F3864"/>
+                </a:solidFill>
+                <a:latin typeface="Arial"/>
+              </a:rPr>
+              <a:t>Paste:</a:t>
+            </a:r>
+          </a:p>
+        </p:txBody>
+      </p:sp>
+      <p:sp>
+        <p:nvSpPr>
+          <p:cNvPr id="7" name="Rectangle 6"/>
+          <p:cNvSpPr/>
+          <p:nvPr/>
+        </p:nvSpPr>
+        <p:spPr>
+          <a:xfrm>
+            <a:off x="548640" y="1645919"/>
+            <a:ext cx="6583680" cy="1188720"/>
+          </a:xfrm>
+          <a:prstGeom prst="rect">
+            <a:avLst/>
+          </a:prstGeom>
+          <a:solidFill>
+            <a:srgbClr val="F2F2F2"/>
+          </a:solidFill>
+          <a:ln>
+            <a:noFill/>
+          </a:ln>
+          <a:effectLst/>
+        </p:spPr>
+        <p:style>
+          <a:lnRef idx="1">
+            <a:schemeClr val="accent1"/>
+          </a:lnRef>
+          <a:fillRef idx="3">
+            <a:schemeClr val="accent1"/>
+          </a:fillRef>
+          <a:effectRef idx="2">
+            <a:schemeClr val="accent1"/>
+          </a:effectRef>
+          <a:fontRef idx="minor">
+            <a:schemeClr val="lt1"/>
+          </a:fontRef>
+        </p:style>
+        <p:txBody>
+          <a:bodyPr rtlCol="0" anchor="ctr"/>
+          <a:lstStyle/>
+          <a:p>
+            <a:pPr algn="ctr"/>
+          </a:p>
+        </p:txBody>
+      </p:sp>
+      <p:sp>
+        <p:nvSpPr>
+          <p:cNvPr id="8" name="TextBox 7"/>
+          <p:cNvSpPr txBox="1"/>
+          <p:nvPr/>
+        </p:nvSpPr>
+        <p:spPr>
+          <a:xfrm>
+            <a:off x="640080" y="1673351"/>
+            <a:ext cx="6400800" cy="1188720"/>
+          </a:xfrm>
+          <a:prstGeom prst="rect">
+            <a:avLst/>
+          </a:prstGeom>
+          <a:noFill/>
+        </p:spPr>
+        <p:txBody>
+          <a:bodyPr wrap="square">
+            <a:spAutoFit/>
+          </a:bodyPr>
+          <a:lstStyle/>
+          <a:p>
+            <a:pPr>
+              <a:spcAft>
+                <a:spcPts val="500"/>
+              </a:spcAft>
+            </a:pPr>
+            <a:r>
+              <a:rPr sz="1200" b="0" i="0">
+                <a:solidFill>
+                  <a:srgbClr val="262626"/>
+                </a:solidFill>
+                <a:latin typeface="Consolas"/>
+              </a:rPr>
+              <a:t>Add VAT, personal income tax, corporate income tax and excises (% of GDP) to the dashboard, under Tax revenue, from the IMF WoRLD file already in raw_data. Follow TaxMacroFiscalDashboard/build/README.md. Do not change anything else. Then rebuild and show me Indonesia.</a:t>
+            </a:r>
+          </a:p>
+        </p:txBody>
+      </p:sp>
+      <p:sp>
+        <p:nvSpPr>
+          <p:cNvPr id="9" name="TextBox 8"/>
+          <p:cNvSpPr txBox="1"/>
+          <p:nvPr/>
+        </p:nvSpPr>
+        <p:spPr>
+          <a:xfrm>
+            <a:off x="548640" y="2971800"/>
+            <a:ext cx="6583680" cy="274320"/>
+          </a:xfrm>
+          <a:prstGeom prst="rect">
+            <a:avLst/>
+          </a:prstGeom>
+          <a:noFill/>
+        </p:spPr>
+        <p:txBody>
+          <a:bodyPr wrap="square">
+            <a:spAutoFit/>
+          </a:bodyPr>
+          <a:lstStyle/>
+          <a:p>
+            <a:pPr>
+              <a:spcAft>
+                <a:spcPts val="500"/>
+              </a:spcAft>
+            </a:pPr>
+            <a:r>
+              <a:rPr sz="1300" b="1" i="0">
+                <a:solidFill>
+                  <a:srgbClr val="1F3864"/>
+                </a:solidFill>
+                <a:latin typeface="Arial"/>
+              </a:rPr>
+              <a:t>Then:</a:t>
+            </a:r>
+          </a:p>
+        </p:txBody>
+      </p:sp>
+      <p:sp>
+        <p:nvSpPr>
+          <p:cNvPr id="10" name="Rectangle 9"/>
+          <p:cNvSpPr/>
+          <p:nvPr/>
+        </p:nvSpPr>
+        <p:spPr>
+          <a:xfrm>
+            <a:off x="548640" y="3291840"/>
+            <a:ext cx="6583680" cy="329184"/>
+          </a:xfrm>
+          <a:prstGeom prst="rect">
+            <a:avLst/>
+          </a:prstGeom>
+          <a:solidFill>
+            <a:srgbClr val="F2F2F2"/>
+          </a:solidFill>
+          <a:ln>
+            <a:noFill/>
+          </a:ln>
+          <a:effectLst/>
+        </p:spPr>
+        <p:style>
+          <a:lnRef idx="1">
+            <a:schemeClr val="accent1"/>
+          </a:lnRef>
+          <a:fillRef idx="3">
+            <a:schemeClr val="accent1"/>
+          </a:fillRef>
+          <a:effectRef idx="2">
+            <a:schemeClr val="accent1"/>
+          </a:effectRef>
+          <a:fontRef idx="minor">
+            <a:schemeClr val="lt1"/>
+          </a:fontRef>
+        </p:style>
+        <p:txBody>
+          <a:bodyPr rtlCol="0" anchor="ctr"/>
+          <a:lstStyle/>
+          <a:p>
+            <a:pPr algn="ctr"/>
+          </a:p>
+        </p:txBody>
+      </p:sp>
+      <p:sp>
+        <p:nvSpPr>
+          <p:cNvPr id="11" name="TextBox 10"/>
+          <p:cNvSpPr txBox="1"/>
+          <p:nvPr/>
+        </p:nvSpPr>
+        <p:spPr>
+          <a:xfrm>
+            <a:off x="640080" y="3319272"/>
+            <a:ext cx="6400800" cy="329184"/>
+          </a:xfrm>
+          <a:prstGeom prst="rect">
+            <a:avLst/>
+          </a:prstGeom>
+          <a:noFill/>
+        </p:spPr>
+        <p:txBody>
+          <a:bodyPr wrap="square">
+            <a:spAutoFit/>
+          </a:bodyPr>
+          <a:lstStyle/>
+          <a:p>
+            <a:pPr>
+              <a:spcAft>
+                <a:spcPts val="500"/>
+              </a:spcAft>
+            </a:pPr>
+            <a:r>
+              <a:rPr sz="1100" b="0" i="0">
+                <a:solidFill>
+                  <a:srgbClr val="262626"/>
+                </a:solidFill>
+                <a:latin typeface="Consolas"/>
+              </a:rPr>
+              <a:t>Commit and push with a clear message.</a:t>
+            </a:r>
+          </a:p>
+        </p:txBody>
+      </p:sp>
+      <p:sp>
+        <p:nvSpPr>
+          <p:cNvPr id="12" name="Rectangle 11"/>
+          <p:cNvSpPr/>
+          <p:nvPr/>
+        </p:nvSpPr>
+        <p:spPr>
+          <a:xfrm>
+            <a:off x="7379208" y="1344168"/>
+            <a:ext cx="4352544" cy="2472309"/>
+          </a:xfrm>
+          <a:prstGeom prst="rect">
+            <a:avLst/>
+          </a:prstGeom>
+          <a:solidFill>
+            <a:srgbClr val="BFBFBF"/>
+          </a:solidFill>
+          <a:ln>
+            <a:noFill/>
+          </a:ln>
+          <a:effectLst/>
+        </p:spPr>
+        <p:style>
+          <a:lnRef idx="1">
+            <a:schemeClr val="accent1"/>
+          </a:lnRef>
+          <a:fillRef idx="3">
+            <a:schemeClr val="accent1"/>
+          </a:fillRef>
+          <a:effectRef idx="2">
+            <a:schemeClr val="accent1"/>
+          </a:effectRef>
+          <a:fontRef idx="minor">
+            <a:schemeClr val="lt1"/>
+          </a:fontRef>
+        </p:style>
+        <p:txBody>
+          <a:bodyPr rtlCol="0" anchor="ctr"/>
+          <a:lstStyle/>
+          <a:p>
+            <a:pPr algn="ctr"/>
+          </a:p>
+        </p:txBody>
+      </p:sp>
+      <p:pic>
+        <p:nvPicPr>
+          <p:cNvPr id="13" name="Picture 12" descr="s_diff.png"/>
+          <p:cNvPicPr>
+            <a:picLocks noChangeAspect="1"/>
+          </p:cNvPicPr>
+          <p:nvPr/>
+        </p:nvPicPr>
+        <p:blipFill>
+          <a:blip r:embed="rId2"/>
+          <a:stretch>
+            <a:fillRect/>
+          </a:stretch>
+        </p:blipFill>
+        <p:spPr>
+          <a:xfrm>
+            <a:off x="7406640" y="1371600"/>
+            <a:ext cx="4297680" cy="2417445"/>
+          </a:xfrm>
+          <a:prstGeom prst="rect">
+            <a:avLst/>
+          </a:prstGeom>
+        </p:spPr>
+      </p:pic>
+      <p:sp>
+        <p:nvSpPr>
+          <p:cNvPr id="14" name="TextBox 13"/>
+          <p:cNvSpPr txBox="1"/>
+          <p:nvPr/>
+        </p:nvSpPr>
+        <p:spPr>
+          <a:xfrm>
+            <a:off x="7406640" y="3834765"/>
+            <a:ext cx="4297680" cy="274320"/>
+          </a:xfrm>
+          <a:prstGeom prst="rect">
+            <a:avLst/>
+          </a:prstGeom>
+          <a:noFill/>
+        </p:spPr>
+        <p:txBody>
+          <a:bodyPr wrap="square">
+            <a:spAutoFit/>
+          </a:bodyPr>
+          <a:lstStyle/>
+          <a:p>
+            <a:pPr>
+              <a:spcAft>
+                <a:spcPts val="500"/>
+              </a:spcAft>
+            </a:pPr>
+            <a:r>
+              <a:rPr sz="1100" b="0" i="1">
+                <a:solidFill>
+                  <a:srgbClr val="404040"/>
+                </a:solidFill>
+                <a:latin typeface="Arial"/>
+              </a:rPr>
+              <a:t>The Changes view: every edit as a diff before you keep it</a:t>
+            </a:r>
+          </a:p>
+        </p:txBody>
+      </p:sp>
+      <p:sp>
+        <p:nvSpPr>
+          <p:cNvPr id="15" name="Rectangle 14"/>
+          <p:cNvSpPr/>
+          <p:nvPr/>
+        </p:nvSpPr>
+        <p:spPr>
+          <a:xfrm>
+            <a:off x="7406640" y="5212080"/>
+            <a:ext cx="4297680" cy="914400"/>
+          </a:xfrm>
+          <a:prstGeom prst="rect">
+            <a:avLst/>
+          </a:prstGeom>
+          <a:solidFill>
+            <a:srgbClr val="EEF3F9"/>
+          </a:solidFill>
+          <a:ln>
+            <a:noFill/>
+          </a:ln>
+          <a:effectLst/>
+        </p:spPr>
+        <p:style>
+          <a:lnRef idx="1">
+            <a:schemeClr val="accent1"/>
+          </a:lnRef>
+          <a:fillRef idx="3">
+            <a:schemeClr val="accent1"/>
+          </a:fillRef>
+          <a:effectRef idx="2">
+            <a:schemeClr val="accent1"/>
+          </a:effectRef>
+          <a:fontRef idx="minor">
+            <a:schemeClr val="lt1"/>
+          </a:fontRef>
+        </p:style>
+        <p:txBody>
+          <a:bodyPr rtlCol="0" anchor="ctr"/>
+          <a:lstStyle/>
+          <a:p>
+            <a:pPr algn="ctr"/>
+          </a:p>
+        </p:txBody>
+      </p:sp>
+      <p:sp>
+        <p:nvSpPr>
+          <p:cNvPr id="16" name="Rectangle 15"/>
+          <p:cNvSpPr/>
+          <p:nvPr/>
+        </p:nvSpPr>
+        <p:spPr>
+          <a:xfrm>
+            <a:off x="7406640" y="5212080"/>
+            <a:ext cx="73152" cy="914400"/>
+          </a:xfrm>
+          <a:prstGeom prst="rect">
+            <a:avLst/>
+          </a:prstGeom>
+          <a:solidFill>
+            <a:srgbClr val="C9A227"/>
+          </a:solidFill>
+          <a:ln>
+            <a:noFill/>
+          </a:ln>
+          <a:effectLst/>
+        </p:spPr>
+        <p:style>
+          <a:lnRef idx="1">
+            <a:schemeClr val="accent1"/>
+          </a:lnRef>
+          <a:fillRef idx="3">
+            <a:schemeClr val="accent1"/>
+          </a:fillRef>
+          <a:effectRef idx="2">
+            <a:schemeClr val="accent1"/>
+          </a:effectRef>
+          <a:fontRef idx="minor">
+            <a:schemeClr val="lt1"/>
+          </a:fontRef>
+        </p:style>
+        <p:txBody>
+          <a:bodyPr rtlCol="0" anchor="ctr"/>
+          <a:lstStyle/>
+          <a:p>
+            <a:pPr algn="ctr"/>
+          </a:p>
+        </p:txBody>
+      </p:sp>
+      <p:sp>
+        <p:nvSpPr>
+          <p:cNvPr id="17" name="TextBox 16"/>
+          <p:cNvSpPr txBox="1"/>
+          <p:nvPr/>
+        </p:nvSpPr>
+        <p:spPr>
+          <a:xfrm>
+            <a:off x="7589520" y="5257800"/>
+            <a:ext cx="4023360" cy="868680"/>
+          </a:xfrm>
+          <a:prstGeom prst="rect">
+            <a:avLst/>
+          </a:prstGeom>
+          <a:noFill/>
+        </p:spPr>
+        <p:txBody>
+          <a:bodyPr wrap="square">
+            <a:spAutoFit/>
+          </a:bodyPr>
+          <a:lstStyle/>
+          <a:p>
+            <a:pPr>
+              <a:spcAft>
+                <a:spcPts val="500"/>
+              </a:spcAft>
+            </a:pPr>
+            <a:r>
+              <a:rPr sz="1200" b="1" i="0">
                 <a:solidFill>
                   <a:srgbClr val="1F3864"/>
                 </a:solidFill>
                 <a:latin typeface="Arial"/>
               </a:rPr>
               <a:t>Check: Indonesia, % of GDP: tax 10.08 · VAT 3.52 · corporate 2.65 · personal 1.79 · excises 1.11</a:t>
+            </a:r>
+          </a:p>
+        </p:txBody>
+      </p:sp>
+    </p:spTree>
+  </p:cSld>
+  <p:clrMapOvr>
+    <a:masterClrMapping/>
+  </p:clrMapOvr>
+</p:sld>
+</file>
+
+<file path=ppt/slides/slide6.xml><?xml version="1.0" encoding="utf-8"?>
+<p:sld xmlns:a="http://schemas.openxmlformats.org/drawingml/2006/main" xmlns:p="http://schemas.openxmlformats.org/presentationml/2006/main" xmlns:r="http://schemas.openxmlformats.org/officeDocument/2006/relationships">
+  <p:cSld>
+    <p:spTree>
+      <p:nvGrpSpPr>
+        <p:cNvPr id="1" name=""/>
+        <p:cNvGrpSpPr/>
+        <p:nvPr/>
+      </p:nvGrpSpPr>
+      <p:grpSpPr/>
+      <p:sp>
+        <p:nvSpPr>
+          <p:cNvPr id="2" name="Rectangle 1"/>
+          <p:cNvSpPr/>
+          <p:nvPr/>
+        </p:nvSpPr>
+        <p:spPr>
+          <a:xfrm>
+            <a:off x="0" y="0"/>
+            <a:ext cx="12191695" cy="109728"/>
+          </a:xfrm>
+          <a:prstGeom prst="rect">
+            <a:avLst/>
+          </a:prstGeom>
+          <a:solidFill>
+            <a:srgbClr val="1F3864"/>
+          </a:solidFill>
+          <a:ln>
+            <a:noFill/>
+          </a:ln>
+          <a:effectLst/>
+        </p:spPr>
+        <p:style>
+          <a:lnRef idx="1">
+            <a:schemeClr val="accent1"/>
+          </a:lnRef>
+          <a:fillRef idx="3">
+            <a:schemeClr val="accent1"/>
+          </a:fillRef>
+          <a:effectRef idx="2">
+            <a:schemeClr val="accent1"/>
+          </a:effectRef>
+          <a:fontRef idx="minor">
+            <a:schemeClr val="lt1"/>
+          </a:fontRef>
+        </p:style>
+        <p:txBody>
+          <a:bodyPr rtlCol="0" anchor="ctr"/>
+          <a:lstStyle/>
+          <a:p>
+            <a:pPr algn="ctr"/>
+          </a:p>
+        </p:txBody>
+      </p:sp>
+      <p:sp>
+        <p:nvSpPr>
+          <p:cNvPr id="3" name="TextBox 2"/>
+          <p:cNvSpPr txBox="1"/>
+          <p:nvPr/>
+        </p:nvSpPr>
+        <p:spPr>
+          <a:xfrm>
+            <a:off x="548640" y="274320"/>
+            <a:ext cx="10972800" cy="320040"/>
+          </a:xfrm>
+          <a:prstGeom prst="rect">
+            <a:avLst/>
+          </a:prstGeom>
+          <a:noFill/>
+        </p:spPr>
+        <p:txBody>
+          <a:bodyPr wrap="square">
+            <a:spAutoFit/>
+          </a:bodyPr>
+          <a:lstStyle/>
+          <a:p>
+            <a:pPr>
+              <a:spcAft>
+                <a:spcPts val="500"/>
+              </a:spcAft>
+            </a:pPr>
+            <a:r>
+              <a:rPr sz="1200" b="1" i="0">
+                <a:solidFill>
+                  <a:srgbClr val="C9A227"/>
+                </a:solidFill>
+                <a:latin typeface="Arial"/>
+              </a:rPr>
+              <a:t>STEP 3 · SAVE YOUR WORK</a:t>
+            </a:r>
+          </a:p>
+        </p:txBody>
+      </p:sp>
+      <p:sp>
+        <p:nvSpPr>
+          <p:cNvPr id="4" name="TextBox 3"/>
+          <p:cNvSpPr txBox="1"/>
+          <p:nvPr/>
+        </p:nvSpPr>
+        <p:spPr>
+          <a:xfrm>
+            <a:off x="548640" y="548640"/>
+            <a:ext cx="10972800" cy="640080"/>
+          </a:xfrm>
+          <a:prstGeom prst="rect">
+            <a:avLst/>
+          </a:prstGeom>
+          <a:noFill/>
+        </p:spPr>
+        <p:txBody>
+          <a:bodyPr wrap="square">
+            <a:spAutoFit/>
+          </a:bodyPr>
+          <a:lstStyle/>
+          <a:p>
+            <a:pPr>
+              <a:spcAft>
+                <a:spcPts val="500"/>
+              </a:spcAft>
+            </a:pPr>
+            <a:r>
+              <a:rPr sz="2800" b="1" i="0">
+                <a:solidFill>
+                  <a:srgbClr val="1F3864"/>
+                </a:solidFill>
+                <a:latin typeface="Arial"/>
+              </a:rPr>
+              <a:t>Send it to GitHub, so the team has it</a:t>
+            </a:r>
+          </a:p>
+        </p:txBody>
+      </p:sp>
+      <p:sp>
+        <p:nvSpPr>
+          <p:cNvPr id="5" name="TextBox 4"/>
+          <p:cNvSpPr txBox="1"/>
+          <p:nvPr/>
+        </p:nvSpPr>
+        <p:spPr>
+          <a:xfrm>
+            <a:off x="548640" y="6446520"/>
+            <a:ext cx="11155680" cy="274320"/>
+          </a:xfrm>
+          <a:prstGeom prst="rect">
+            <a:avLst/>
+          </a:prstGeom>
+          <a:noFill/>
+        </p:spPr>
+        <p:txBody>
+          <a:bodyPr wrap="square">
+            <a:spAutoFit/>
+          </a:bodyPr>
+          <a:lstStyle/>
+          <a:p>
+            <a:pPr>
+              <a:spcAft>
+                <a:spcPts val="500"/>
+              </a:spcAft>
+            </a:pPr>
+            <a:r>
+              <a:rPr sz="900" b="0" i="0">
+                <a:solidFill>
+                  <a:srgbClr val="808080"/>
+                </a:solidFill>
+                <a:latin typeface="Arial"/>
+              </a:rPr>
+              <a:t>AI Tools Quick Start  ·  GitHub Copilot app  ·  October 2026  ·  Screens change over time</a:t>
+            </a:r>
+          </a:p>
+        </p:txBody>
+      </p:sp>
+      <p:sp>
+        <p:nvSpPr>
+          <p:cNvPr id="6" name="Oval 5"/>
+          <p:cNvSpPr/>
+          <p:nvPr/>
+        </p:nvSpPr>
+        <p:spPr>
+          <a:xfrm>
+            <a:off x="548640" y="1463040"/>
+            <a:ext cx="384048" cy="384048"/>
+          </a:xfrm>
+          <a:prstGeom prst="ellipse">
+            <a:avLst/>
+          </a:prstGeom>
+          <a:solidFill>
+            <a:srgbClr val="2E75B6"/>
+          </a:solidFill>
+          <a:ln>
+            <a:noFill/>
+          </a:ln>
+          <a:effectLst/>
+        </p:spPr>
+        <p:style>
+          <a:lnRef idx="1">
+            <a:schemeClr val="accent1"/>
+          </a:lnRef>
+          <a:fillRef idx="3">
+            <a:schemeClr val="accent1"/>
+          </a:fillRef>
+          <a:effectRef idx="2">
+            <a:schemeClr val="accent1"/>
+          </a:effectRef>
+          <a:fontRef idx="minor">
+            <a:schemeClr val="lt1"/>
+          </a:fontRef>
+        </p:style>
+        <p:txBody>
+          <a:bodyPr rtlCol="0" anchor="ctr" lIns="0" rIns="0"/>
+          <a:lstStyle/>
+          <a:p>
+            <a:pPr algn="ctr"/>
+            <a:r>
+              <a:rPr sz="1400" b="1">
+                <a:solidFill>
+                  <a:srgbClr val="FFFFFF"/>
+                </a:solidFill>
+                <a:latin typeface="Arial"/>
+              </a:rPr>
+              <a:t>1</a:t>
+            </a:r>
+          </a:p>
+        </p:txBody>
+      </p:sp>
+      <p:sp>
+        <p:nvSpPr>
+          <p:cNvPr id="7" name="TextBox 6"/>
+          <p:cNvSpPr txBox="1"/>
+          <p:nvPr/>
+        </p:nvSpPr>
+        <p:spPr>
+          <a:xfrm>
+            <a:off x="1051560" y="1426464"/>
+            <a:ext cx="5166360" cy="320040"/>
+          </a:xfrm>
+          <a:prstGeom prst="rect">
+            <a:avLst/>
+          </a:prstGeom>
+          <a:noFill/>
+        </p:spPr>
+        <p:txBody>
+          <a:bodyPr wrap="square">
+            <a:spAutoFit/>
+          </a:bodyPr>
+          <a:lstStyle/>
+          <a:p>
+            <a:pPr>
+              <a:spcAft>
+                <a:spcPts val="500"/>
+              </a:spcAft>
+            </a:pPr>
+            <a:r>
+              <a:rPr sz="1500" b="1" i="0">
+                <a:solidFill>
+                  <a:srgbClr val="1F3864"/>
+                </a:solidFill>
+                <a:latin typeface="Arial"/>
+              </a:rPr>
+              <a:t>Ask Copilot</a:t>
+            </a:r>
+          </a:p>
+        </p:txBody>
+      </p:sp>
+      <p:sp>
+        <p:nvSpPr>
+          <p:cNvPr id="8" name="TextBox 7"/>
+          <p:cNvSpPr txBox="1"/>
+          <p:nvPr/>
+        </p:nvSpPr>
+        <p:spPr>
+          <a:xfrm>
+            <a:off x="1051560" y="1737360"/>
+            <a:ext cx="5166360" cy="914400"/>
+          </a:xfrm>
+          <a:prstGeom prst="rect">
+            <a:avLst/>
+          </a:prstGeom>
+          <a:noFill/>
+        </p:spPr>
+        <p:txBody>
+          <a:bodyPr wrap="square">
+            <a:spAutoFit/>
+          </a:bodyPr>
+          <a:lstStyle/>
+          <a:p>
+            <a:pPr>
+              <a:spcAft>
+                <a:spcPts val="500"/>
+              </a:spcAft>
+            </a:pPr>
+            <a:r>
+              <a:rPr sz="1200" b="0" i="0">
+                <a:solidFill>
+                  <a:srgbClr val="404040"/>
+                </a:solidFill>
+                <a:latin typeface="Arial"/>
+              </a:rPr>
+              <a:t>Type: Commit and push with a clear message. Copilot shows what it will commit; approve it.</a:t>
+            </a:r>
+          </a:p>
+        </p:txBody>
+      </p:sp>
+      <p:sp>
+        <p:nvSpPr>
+          <p:cNvPr id="9" name="Oval 8"/>
+          <p:cNvSpPr/>
+          <p:nvPr/>
+        </p:nvSpPr>
+        <p:spPr>
+          <a:xfrm>
+            <a:off x="548640" y="2651760"/>
+            <a:ext cx="384048" cy="384048"/>
+          </a:xfrm>
+          <a:prstGeom prst="ellipse">
+            <a:avLst/>
+          </a:prstGeom>
+          <a:solidFill>
+            <a:srgbClr val="2E75B6"/>
+          </a:solidFill>
+          <a:ln>
+            <a:noFill/>
+          </a:ln>
+          <a:effectLst/>
+        </p:spPr>
+        <p:style>
+          <a:lnRef idx="1">
+            <a:schemeClr val="accent1"/>
+          </a:lnRef>
+          <a:fillRef idx="3">
+            <a:schemeClr val="accent1"/>
+          </a:fillRef>
+          <a:effectRef idx="2">
+            <a:schemeClr val="accent1"/>
+          </a:effectRef>
+          <a:fontRef idx="minor">
+            <a:schemeClr val="lt1"/>
+          </a:fontRef>
+        </p:style>
+        <p:txBody>
+          <a:bodyPr rtlCol="0" anchor="ctr" lIns="0" rIns="0"/>
+          <a:lstStyle/>
+          <a:p>
+            <a:pPr algn="ctr"/>
+            <a:r>
+              <a:rPr sz="1400" b="1">
+                <a:solidFill>
+                  <a:srgbClr val="FFFFFF"/>
+                </a:solidFill>
+                <a:latin typeface="Arial"/>
+              </a:rPr>
+              <a:t>2</a:t>
+            </a:r>
+          </a:p>
+        </p:txBody>
+      </p:sp>
+      <p:sp>
+        <p:nvSpPr>
+          <p:cNvPr id="10" name="TextBox 9"/>
+          <p:cNvSpPr txBox="1"/>
+          <p:nvPr/>
+        </p:nvSpPr>
+        <p:spPr>
+          <a:xfrm>
+            <a:off x="1051560" y="2615184"/>
+            <a:ext cx="5166360" cy="320040"/>
+          </a:xfrm>
+          <a:prstGeom prst="rect">
+            <a:avLst/>
+          </a:prstGeom>
+          <a:noFill/>
+        </p:spPr>
+        <p:txBody>
+          <a:bodyPr wrap="square">
+            <a:spAutoFit/>
+          </a:bodyPr>
+          <a:lstStyle/>
+          <a:p>
+            <a:pPr>
+              <a:spcAft>
+                <a:spcPts val="500"/>
+              </a:spcAft>
+            </a:pPr>
+            <a:r>
+              <a:rPr sz="1500" b="1" i="0">
+                <a:solidFill>
+                  <a:srgbClr val="1F3864"/>
+                </a:solidFill>
+                <a:latin typeface="Arial"/>
+              </a:rPr>
+              <a:t>Or use the script</a:t>
+            </a:r>
+          </a:p>
+        </p:txBody>
+      </p:sp>
+      <p:sp>
+        <p:nvSpPr>
+          <p:cNvPr id="11" name="TextBox 10"/>
+          <p:cNvSpPr txBox="1"/>
+          <p:nvPr/>
+        </p:nvSpPr>
+        <p:spPr>
+          <a:xfrm>
+            <a:off x="1051560" y="2926080"/>
+            <a:ext cx="5166360" cy="914400"/>
+          </a:xfrm>
+          <a:prstGeom prst="rect">
+            <a:avLst/>
+          </a:prstGeom>
+          <a:noFill/>
+        </p:spPr>
+        <p:txBody>
+          <a:bodyPr wrap="square">
+            <a:spAutoFit/>
+          </a:bodyPr>
+          <a:lstStyle/>
+          <a:p>
+            <a:pPr>
+              <a:spcAft>
+                <a:spcPts val="500"/>
+              </a:spcAft>
+            </a:pPr>
+            <a:r>
+              <a:rPr sz="1200" b="0" i="0">
+                <a:solidFill>
+                  <a:srgbClr val="404040"/>
+                </a:solidFill>
+                <a:latin typeface="Arial"/>
+              </a:rPr>
+              <a:t>Double-click SyncRepo.bat in the repo folder (pull, commit, push).</a:t>
+            </a:r>
+          </a:p>
+        </p:txBody>
+      </p:sp>
+      <p:sp>
+        <p:nvSpPr>
+          <p:cNvPr id="12" name="Oval 11"/>
+          <p:cNvSpPr/>
+          <p:nvPr/>
+        </p:nvSpPr>
+        <p:spPr>
+          <a:xfrm>
+            <a:off x="548640" y="3840480"/>
+            <a:ext cx="384048" cy="384048"/>
+          </a:xfrm>
+          <a:prstGeom prst="ellipse">
+            <a:avLst/>
+          </a:prstGeom>
+          <a:solidFill>
+            <a:srgbClr val="2E75B6"/>
+          </a:solidFill>
+          <a:ln>
+            <a:noFill/>
+          </a:ln>
+          <a:effectLst/>
+        </p:spPr>
+        <p:style>
+          <a:lnRef idx="1">
+            <a:schemeClr val="accent1"/>
+          </a:lnRef>
+          <a:fillRef idx="3">
+            <a:schemeClr val="accent1"/>
+          </a:fillRef>
+          <a:effectRef idx="2">
+            <a:schemeClr val="accent1"/>
+          </a:effectRef>
+          <a:fontRef idx="minor">
+            <a:schemeClr val="lt1"/>
+          </a:fontRef>
+        </p:style>
+        <p:txBody>
+          <a:bodyPr rtlCol="0" anchor="ctr" lIns="0" rIns="0"/>
+          <a:lstStyle/>
+          <a:p>
+            <a:pPr algn="ctr"/>
+            <a:r>
+              <a:rPr sz="1400" b="1">
+                <a:solidFill>
+                  <a:srgbClr val="FFFFFF"/>
+                </a:solidFill>
+                <a:latin typeface="Arial"/>
+              </a:rPr>
+              <a:t>3</a:t>
+            </a:r>
+          </a:p>
+        </p:txBody>
+      </p:sp>
+      <p:sp>
+        <p:nvSpPr>
+          <p:cNvPr id="13" name="TextBox 12"/>
+          <p:cNvSpPr txBox="1"/>
+          <p:nvPr/>
+        </p:nvSpPr>
+        <p:spPr>
+          <a:xfrm>
+            <a:off x="1051560" y="3803904"/>
+            <a:ext cx="5166360" cy="320040"/>
+          </a:xfrm>
+          <a:prstGeom prst="rect">
+            <a:avLst/>
+          </a:prstGeom>
+          <a:noFill/>
+        </p:spPr>
+        <p:txBody>
+          <a:bodyPr wrap="square">
+            <a:spAutoFit/>
+          </a:bodyPr>
+          <a:lstStyle/>
+          <a:p>
+            <a:pPr>
+              <a:spcAft>
+                <a:spcPts val="500"/>
+              </a:spcAft>
+            </a:pPr>
+            <a:r>
+              <a:rPr sz="1500" b="1" i="0">
+                <a:solidFill>
+                  <a:srgbClr val="1F3864"/>
+                </a:solidFill>
+                <a:latin typeface="Arial"/>
+              </a:rPr>
+              <a:t>Check</a:t>
+            </a:r>
+          </a:p>
+        </p:txBody>
+      </p:sp>
+      <p:sp>
+        <p:nvSpPr>
+          <p:cNvPr id="14" name="TextBox 13"/>
+          <p:cNvSpPr txBox="1"/>
+          <p:nvPr/>
+        </p:nvSpPr>
+        <p:spPr>
+          <a:xfrm>
+            <a:off x="1051560" y="4114800"/>
+            <a:ext cx="5166360" cy="914400"/>
+          </a:xfrm>
+          <a:prstGeom prst="rect">
+            <a:avLst/>
+          </a:prstGeom>
+          <a:noFill/>
+        </p:spPr>
+        <p:txBody>
+          <a:bodyPr wrap="square">
+            <a:spAutoFit/>
+          </a:bodyPr>
+          <a:lstStyle/>
+          <a:p>
+            <a:pPr>
+              <a:spcAft>
+                <a:spcPts val="500"/>
+              </a:spcAft>
+            </a:pPr>
+            <a:r>
+              <a:rPr sz="1200" b="0" i="0">
+                <a:solidFill>
+                  <a:srgbClr val="404040"/>
+                </a:solidFill>
+                <a:latin typeface="Arial"/>
+              </a:rPr>
+              <a:t>On github.com/cpmodel/new-ai-tools your change shows as the latest commit.</a:t>
+            </a:r>
+          </a:p>
+        </p:txBody>
+      </p:sp>
+      <p:sp>
+        <p:nvSpPr>
+          <p:cNvPr id="15" name="Rectangle 14"/>
+          <p:cNvSpPr/>
+          <p:nvPr/>
+        </p:nvSpPr>
+        <p:spPr>
+          <a:xfrm>
+            <a:off x="6583680" y="1463040"/>
+            <a:ext cx="5029200" cy="1828800"/>
+          </a:xfrm>
+          <a:prstGeom prst="rect">
+            <a:avLst/>
+          </a:prstGeom>
+          <a:solidFill>
+            <a:srgbClr val="EEF3F9"/>
+          </a:solidFill>
+          <a:ln>
+            <a:noFill/>
+          </a:ln>
+          <a:effectLst/>
+        </p:spPr>
+        <p:style>
+          <a:lnRef idx="1">
+            <a:schemeClr val="accent1"/>
+          </a:lnRef>
+          <a:fillRef idx="3">
+            <a:schemeClr val="accent1"/>
+          </a:fillRef>
+          <a:effectRef idx="2">
+            <a:schemeClr val="accent1"/>
+          </a:effectRef>
+          <a:fontRef idx="minor">
+            <a:schemeClr val="lt1"/>
+          </a:fontRef>
+        </p:style>
+        <p:txBody>
+          <a:bodyPr rtlCol="0" anchor="ctr"/>
+          <a:lstStyle/>
+          <a:p>
+            <a:pPr algn="ctr"/>
+          </a:p>
+        </p:txBody>
+      </p:sp>
+      <p:sp>
+        <p:nvSpPr>
+          <p:cNvPr id="16" name="Rectangle 15"/>
+          <p:cNvSpPr/>
+          <p:nvPr/>
+        </p:nvSpPr>
+        <p:spPr>
+          <a:xfrm>
+            <a:off x="6583680" y="1463040"/>
+            <a:ext cx="73152" cy="1828800"/>
+          </a:xfrm>
+          <a:prstGeom prst="rect">
+            <a:avLst/>
+          </a:prstGeom>
+          <a:solidFill>
+            <a:srgbClr val="C9A227"/>
+          </a:solidFill>
+          <a:ln>
+            <a:noFill/>
+          </a:ln>
+          <a:effectLst/>
+        </p:spPr>
+        <p:style>
+          <a:lnRef idx="1">
+            <a:schemeClr val="accent1"/>
+          </a:lnRef>
+          <a:fillRef idx="3">
+            <a:schemeClr val="accent1"/>
+          </a:fillRef>
+          <a:effectRef idx="2">
+            <a:schemeClr val="accent1"/>
+          </a:effectRef>
+          <a:fontRef idx="minor">
+            <a:schemeClr val="lt1"/>
+          </a:fontRef>
+        </p:style>
+        <p:txBody>
+          <a:bodyPr rtlCol="0" anchor="ctr"/>
+          <a:lstStyle/>
+          <a:p>
+            <a:pPr algn="ctr"/>
+          </a:p>
+        </p:txBody>
+      </p:sp>
+      <p:sp>
+        <p:nvSpPr>
+          <p:cNvPr id="17" name="TextBox 16"/>
+          <p:cNvSpPr txBox="1"/>
+          <p:nvPr/>
+        </p:nvSpPr>
+        <p:spPr>
+          <a:xfrm>
+            <a:off x="6812280" y="1554480"/>
+            <a:ext cx="4663440" cy="365760"/>
+          </a:xfrm>
+          <a:prstGeom prst="rect">
+            <a:avLst/>
+          </a:prstGeom>
+          <a:noFill/>
+        </p:spPr>
+        <p:txBody>
+          <a:bodyPr wrap="square">
+            <a:spAutoFit/>
+          </a:bodyPr>
+          <a:lstStyle/>
+          <a:p>
+            <a:pPr>
+              <a:spcAft>
+                <a:spcPts val="500"/>
+              </a:spcAft>
+            </a:pPr>
+            <a:r>
+              <a:rPr sz="1500" b="1" i="0">
+                <a:solidFill>
+                  <a:srgbClr val="1F3864"/>
+                </a:solidFill>
+                <a:latin typeface="Arial"/>
+              </a:rPr>
+              <a:t>Appendix: with Claude instead</a:t>
+            </a:r>
+          </a:p>
+        </p:txBody>
+      </p:sp>
+      <p:sp>
+        <p:nvSpPr>
+          <p:cNvPr id="18" name="TextBox 17"/>
+          <p:cNvSpPr txBox="1"/>
+          <p:nvPr/>
+        </p:nvSpPr>
+        <p:spPr>
+          <a:xfrm>
+            <a:off x="6812280" y="1965960"/>
+            <a:ext cx="4663440" cy="1280160"/>
+          </a:xfrm>
+          <a:prstGeom prst="rect">
+            <a:avLst/>
+          </a:prstGeom>
+          <a:noFill/>
+        </p:spPr>
+        <p:txBody>
+          <a:bodyPr wrap="square">
+            <a:spAutoFit/>
+          </a:bodyPr>
+          <a:lstStyle/>
+          <a:p>
+            <a:pPr>
+              <a:spcAft>
+                <a:spcPts val="500"/>
+              </a:spcAft>
+            </a:pPr>
+            <a:r>
+              <a:rPr sz="1300" b="0" i="0">
+                <a:solidFill>
+                  <a:srgbClr val="404040"/>
+                </a:solidFill>
+                <a:latin typeface="Arial"/>
+              </a:rPr>
+              <a:t>With Claude instead: on claude.ai make a Project, add excise_diagnostic_process.md, switch on Research, and paste the same prompts.</a:t>
+            </a:r>
+          </a:p>
+        </p:txBody>
+      </p:sp>
+      <p:sp>
+        <p:nvSpPr>
+          <p:cNvPr id="19" name="TextBox 18"/>
+          <p:cNvSpPr txBox="1"/>
+          <p:nvPr/>
+        </p:nvSpPr>
+        <p:spPr>
+          <a:xfrm>
+            <a:off x="548640" y="5394960"/>
+            <a:ext cx="11155680" cy="822960"/>
+          </a:xfrm>
+          <a:prstGeom prst="rect">
+            <a:avLst/>
+          </a:prstGeom>
+          <a:noFill/>
+        </p:spPr>
+        <p:txBody>
+          <a:bodyPr wrap="square">
+            <a:spAutoFit/>
+          </a:bodyPr>
+          <a:lstStyle/>
+          <a:p>
+            <a:pPr>
+              <a:spcAft>
+                <a:spcPts val="500"/>
+              </a:spcAft>
+            </a:pPr>
+            <a:r>
+              <a:rPr sz="1000" b="0" i="1">
+                <a:solidFill>
+                  <a:srgbClr val="808080"/>
+                </a:solidFill>
+                <a:latin typeface="Arial"/>
+              </a:rPr>
+              <a:t>Screenshots: GitHub, "GitHub Copilot app for Beginners" (github.com/github/copilot-app-for-beginners), MIT License, Copyright GitHub, Inc. The model names in them are examples; your screen will differ slightly.</a:t>
             </a:r>
           </a:p>
         </p:txBody>

</xml_diff>